<commit_message>
Add museum images and update PPTX with photo placeholders
Generated styled placeholder images for all 10 venues using Pillow,
embedded into Slide 3 (museum cases) and Slide 7 (Xi'an survey).
Each image uses the museum's actual color palette with descriptions.

https://claude.ai/code/session_01SkU8WweCCFJ2Yz3RBHEU9s
</commit_message>
<xml_diff>
--- a/西安文化机构导视系统调研报告.pptx
+++ b/西安文化机构导视系统调研报告.pptx
@@ -5328,7 +5328,7 @@
         <p:spPr>
           <a:xfrm>
             <a:off x="2194560" y="164592"/>
-            <a:ext cx="9784080" cy="1417320"/>
+            <a:ext cx="9784080" cy="1481328"/>
           </a:xfrm>
           <a:prstGeom prst="rect">
             <a:avLst/>
@@ -5371,7 +5371,7 @@
         <p:spPr>
           <a:xfrm>
             <a:off x="2194560" y="164592"/>
-            <a:ext cx="73152" cy="1417320"/>
+            <a:ext cx="73152" cy="1481328"/>
           </a:xfrm>
           <a:prstGeom prst="rect">
             <a:avLst/>
@@ -5405,9 +5405,33 @@
           </a:p>
         </p:txBody>
       </p:sp>
-      <p:sp>
-        <p:nvSpPr>
-          <p:cNvPr id="16" name="TextBox 15"/>
+      <p:pic>
+        <p:nvPicPr>
+          <p:cNvPr id="16" name="Picture 15" descr="gugong.jpg"/>
+          <p:cNvPicPr>
+            <a:picLocks noChangeAspect="1"/>
+          </p:cNvPicPr>
+          <p:nvPr/>
+        </p:nvPicPr>
+        <p:blipFill>
+          <a:blip r:embed="rId2"/>
+          <a:stretch>
+            <a:fillRect/>
+          </a:stretch>
+        </p:blipFill>
+        <p:spPr>
+          <a:xfrm>
+            <a:off x="9308592" y="237744"/>
+            <a:ext cx="2596896" cy="1335024"/>
+          </a:xfrm>
+          <a:prstGeom prst="rect">
+            <a:avLst/>
+          </a:prstGeom>
+        </p:spPr>
+      </p:pic>
+      <p:sp>
+        <p:nvSpPr>
+          <p:cNvPr id="17" name="TextBox 16"/>
           <p:cNvSpPr txBox="1"/>
           <p:nvPr/>
         </p:nvSpPr>
@@ -5442,7 +5466,7 @@
       </p:sp>
       <p:sp>
         <p:nvSpPr>
-          <p:cNvPr id="17" name="TextBox 16"/>
+          <p:cNvPr id="18" name="TextBox 17"/>
           <p:cNvSpPr txBox="1"/>
           <p:nvPr/>
         </p:nvSpPr>
@@ -5477,7 +5501,7 @@
       </p:sp>
       <p:sp>
         <p:nvSpPr>
-          <p:cNvPr id="18" name="Oval 17"/>
+          <p:cNvPr id="19" name="Oval 18"/>
           <p:cNvSpPr/>
           <p:nvPr/>
         </p:nvSpPr>
@@ -5520,7 +5544,7 @@
       </p:sp>
       <p:sp>
         <p:nvSpPr>
-          <p:cNvPr id="19" name="Oval 18"/>
+          <p:cNvPr id="20" name="Oval 19"/>
           <p:cNvSpPr/>
           <p:nvPr/>
         </p:nvSpPr>
@@ -5563,7 +5587,7 @@
       </p:sp>
       <p:sp>
         <p:nvSpPr>
-          <p:cNvPr id="20" name="Oval 19"/>
+          <p:cNvPr id="21" name="Oval 20"/>
           <p:cNvSpPr/>
           <p:nvPr/>
         </p:nvSpPr>
@@ -5606,7 +5630,7 @@
       </p:sp>
       <p:sp>
         <p:nvSpPr>
-          <p:cNvPr id="21" name="Oval 20"/>
+          <p:cNvPr id="22" name="Oval 21"/>
           <p:cNvSpPr/>
           <p:nvPr/>
         </p:nvSpPr>
@@ -5649,7 +5673,7 @@
       </p:sp>
       <p:sp>
         <p:nvSpPr>
-          <p:cNvPr id="22" name="TextBox 21"/>
+          <p:cNvPr id="23" name="TextBox 22"/>
           <p:cNvSpPr txBox="1"/>
           <p:nvPr/>
         </p:nvSpPr>
@@ -5684,14 +5708,14 @@
       </p:sp>
       <p:sp>
         <p:nvSpPr>
-          <p:cNvPr id="23" name="TextBox 22"/>
+          <p:cNvPr id="24" name="TextBox 23"/>
           <p:cNvSpPr txBox="1"/>
           <p:nvPr/>
         </p:nvSpPr>
         <p:spPr>
           <a:xfrm>
             <a:off x="4389120" y="621792"/>
-            <a:ext cx="7406640" cy="777240"/>
+            <a:ext cx="4754880" cy="868680"/>
           </a:xfrm>
           <a:prstGeom prst="rect">
             <a:avLst/>
@@ -5720,14 +5744,14 @@
       </p:sp>
       <p:sp>
         <p:nvSpPr>
-          <p:cNvPr id="24" name="Rectangle 23"/>
+          <p:cNvPr id="25" name="Rectangle 24"/>
           <p:cNvSpPr/>
           <p:nvPr/>
         </p:nvSpPr>
         <p:spPr>
           <a:xfrm>
-            <a:off x="2194560" y="1673352"/>
-            <a:ext cx="9784080" cy="1417320"/>
+            <a:off x="2194560" y="1700784"/>
+            <a:ext cx="9784080" cy="1481328"/>
           </a:xfrm>
           <a:prstGeom prst="rect">
             <a:avLst/>
@@ -5763,14 +5787,14 @@
       </p:sp>
       <p:sp>
         <p:nvSpPr>
-          <p:cNvPr id="25" name="Rectangle 24"/>
+          <p:cNvPr id="26" name="Rectangle 25"/>
           <p:cNvSpPr/>
           <p:nvPr/>
         </p:nvSpPr>
         <p:spPr>
           <a:xfrm>
-            <a:off x="2194560" y="1673352"/>
-            <a:ext cx="73152" cy="1417320"/>
+            <a:off x="2194560" y="1700784"/>
+            <a:ext cx="73152" cy="1481328"/>
           </a:xfrm>
           <a:prstGeom prst="rect">
             <a:avLst/>
@@ -5804,15 +5828,39 @@
           </a:p>
         </p:txBody>
       </p:sp>
-      <p:sp>
-        <p:nvSpPr>
-          <p:cNvPr id="26" name="TextBox 25"/>
-          <p:cNvSpPr txBox="1"/>
-          <p:nvPr/>
-        </p:nvSpPr>
-        <p:spPr>
-          <a:xfrm>
-            <a:off x="2377440" y="1810512"/>
+      <p:pic>
+        <p:nvPicPr>
+          <p:cNvPr id="27" name="Picture 26" descr="suzhou.jpg"/>
+          <p:cNvPicPr>
+            <a:picLocks noChangeAspect="1"/>
+          </p:cNvPicPr>
+          <p:nvPr/>
+        </p:nvPicPr>
+        <p:blipFill>
+          <a:blip r:embed="rId3"/>
+          <a:stretch>
+            <a:fillRect/>
+          </a:stretch>
+        </p:blipFill>
+        <p:spPr>
+          <a:xfrm>
+            <a:off x="9308592" y="1773936"/>
+            <a:ext cx="2596896" cy="1335024"/>
+          </a:xfrm>
+          <a:prstGeom prst="rect">
+            <a:avLst/>
+          </a:prstGeom>
+        </p:spPr>
+      </p:pic>
+      <p:sp>
+        <p:nvSpPr>
+          <p:cNvPr id="28" name="TextBox 27"/>
+          <p:cNvSpPr txBox="1"/>
+          <p:nvPr/>
+        </p:nvSpPr>
+        <p:spPr>
+          <a:xfrm>
+            <a:off x="2377440" y="1837944"/>
             <a:ext cx="1828800" cy="411480"/>
           </a:xfrm>
           <a:prstGeom prst="rect">
@@ -5841,13 +5889,13 @@
       </p:sp>
       <p:sp>
         <p:nvSpPr>
-          <p:cNvPr id="27" name="TextBox 26"/>
-          <p:cNvSpPr txBox="1"/>
-          <p:nvPr/>
-        </p:nvSpPr>
-        <p:spPr>
-          <a:xfrm>
-            <a:off x="2377440" y="2176272"/>
+          <p:cNvPr id="29" name="TextBox 28"/>
+          <p:cNvSpPr txBox="1"/>
+          <p:nvPr/>
+        </p:nvSpPr>
+        <p:spPr>
+          <a:xfrm>
+            <a:off x="2377440" y="2203704"/>
             <a:ext cx="1828800" cy="274320"/>
           </a:xfrm>
           <a:prstGeom prst="rect">
@@ -5876,13 +5924,13 @@
       </p:sp>
       <p:sp>
         <p:nvSpPr>
-          <p:cNvPr id="28" name="Oval 27"/>
+          <p:cNvPr id="30" name="Oval 29"/>
           <p:cNvSpPr/>
           <p:nvPr/>
         </p:nvSpPr>
         <p:spPr>
           <a:xfrm>
-            <a:off x="2377440" y="2542032"/>
+            <a:off x="2377440" y="2569464"/>
             <a:ext cx="201168" cy="201168"/>
           </a:xfrm>
           <a:prstGeom prst="ellipse">
@@ -5919,13 +5967,13 @@
       </p:sp>
       <p:sp>
         <p:nvSpPr>
-          <p:cNvPr id="29" name="Oval 28"/>
+          <p:cNvPr id="31" name="Oval 30"/>
           <p:cNvSpPr/>
           <p:nvPr/>
         </p:nvSpPr>
         <p:spPr>
           <a:xfrm>
-            <a:off x="2633472" y="2542032"/>
+            <a:off x="2633472" y="2569464"/>
             <a:ext cx="201168" cy="201168"/>
           </a:xfrm>
           <a:prstGeom prst="ellipse">
@@ -5962,13 +6010,13 @@
       </p:sp>
       <p:sp>
         <p:nvSpPr>
-          <p:cNvPr id="30" name="Oval 29"/>
+          <p:cNvPr id="32" name="Oval 31"/>
           <p:cNvSpPr/>
           <p:nvPr/>
         </p:nvSpPr>
         <p:spPr>
           <a:xfrm>
-            <a:off x="2889504" y="2542032"/>
+            <a:off x="2889504" y="2569464"/>
             <a:ext cx="201168" cy="201168"/>
           </a:xfrm>
           <a:prstGeom prst="ellipse">
@@ -6005,13 +6053,13 @@
       </p:sp>
       <p:sp>
         <p:nvSpPr>
-          <p:cNvPr id="31" name="Oval 30"/>
+          <p:cNvPr id="33" name="Oval 32"/>
           <p:cNvSpPr/>
           <p:nvPr/>
         </p:nvSpPr>
         <p:spPr>
           <a:xfrm>
-            <a:off x="3145536" y="2542032"/>
+            <a:off x="3145536" y="2569464"/>
             <a:ext cx="201168" cy="201168"/>
           </a:xfrm>
           <a:prstGeom prst="ellipse">
@@ -6048,13 +6096,13 @@
       </p:sp>
       <p:sp>
         <p:nvSpPr>
-          <p:cNvPr id="32" name="TextBox 31"/>
-          <p:cNvSpPr txBox="1"/>
-          <p:nvPr/>
-        </p:nvSpPr>
-        <p:spPr>
-          <a:xfrm>
-            <a:off x="4389120" y="1810512"/>
+          <p:cNvPr id="34" name="TextBox 33"/>
+          <p:cNvSpPr txBox="1"/>
+          <p:nvPr/>
+        </p:nvSpPr>
+        <p:spPr>
+          <a:xfrm>
+            <a:off x="4389120" y="1837944"/>
             <a:ext cx="2286000" cy="320040"/>
           </a:xfrm>
           <a:prstGeom prst="rect">
@@ -6083,14 +6131,14 @@
       </p:sp>
       <p:sp>
         <p:nvSpPr>
-          <p:cNvPr id="33" name="TextBox 32"/>
-          <p:cNvSpPr txBox="1"/>
-          <p:nvPr/>
-        </p:nvSpPr>
-        <p:spPr>
-          <a:xfrm>
-            <a:off x="4389120" y="2130552"/>
-            <a:ext cx="7406640" cy="777240"/>
+          <p:cNvPr id="35" name="TextBox 34"/>
+          <p:cNvSpPr txBox="1"/>
+          <p:nvPr/>
+        </p:nvSpPr>
+        <p:spPr>
+          <a:xfrm>
+            <a:off x="4389120" y="2157984"/>
+            <a:ext cx="4754880" cy="868680"/>
           </a:xfrm>
           <a:prstGeom prst="rect">
             <a:avLst/>
@@ -6119,14 +6167,14 @@
       </p:sp>
       <p:sp>
         <p:nvSpPr>
-          <p:cNvPr id="34" name="Rectangle 33"/>
+          <p:cNvPr id="36" name="Rectangle 35"/>
           <p:cNvSpPr/>
           <p:nvPr/>
         </p:nvSpPr>
         <p:spPr>
           <a:xfrm>
-            <a:off x="2194560" y="3182112"/>
-            <a:ext cx="9784080" cy="1417320"/>
+            <a:off x="2194560" y="3236976"/>
+            <a:ext cx="9784080" cy="1481328"/>
           </a:xfrm>
           <a:prstGeom prst="rect">
             <a:avLst/>
@@ -6162,14 +6210,14 @@
       </p:sp>
       <p:sp>
         <p:nvSpPr>
-          <p:cNvPr id="35" name="Rectangle 34"/>
+          <p:cNvPr id="37" name="Rectangle 36"/>
           <p:cNvSpPr/>
           <p:nvPr/>
         </p:nvSpPr>
         <p:spPr>
           <a:xfrm>
-            <a:off x="2194560" y="3182112"/>
-            <a:ext cx="73152" cy="1417320"/>
+            <a:off x="2194560" y="3236976"/>
+            <a:ext cx="73152" cy="1481328"/>
           </a:xfrm>
           <a:prstGeom prst="rect">
             <a:avLst/>
@@ -6203,15 +6251,39 @@
           </a:p>
         </p:txBody>
       </p:sp>
-      <p:sp>
-        <p:nvSpPr>
-          <p:cNvPr id="36" name="TextBox 35"/>
-          <p:cNvSpPr txBox="1"/>
-          <p:nvPr/>
-        </p:nvSpPr>
-        <p:spPr>
-          <a:xfrm>
-            <a:off x="2377440" y="3319272"/>
+      <p:pic>
+        <p:nvPicPr>
+          <p:cNvPr id="38" name="Picture 37" descr="shanghai.jpg"/>
+          <p:cNvPicPr>
+            <a:picLocks noChangeAspect="1"/>
+          </p:cNvPicPr>
+          <p:nvPr/>
+        </p:nvPicPr>
+        <p:blipFill>
+          <a:blip r:embed="rId4"/>
+          <a:stretch>
+            <a:fillRect/>
+          </a:stretch>
+        </p:blipFill>
+        <p:spPr>
+          <a:xfrm>
+            <a:off x="9308592" y="3310128"/>
+            <a:ext cx="2596896" cy="1335024"/>
+          </a:xfrm>
+          <a:prstGeom prst="rect">
+            <a:avLst/>
+          </a:prstGeom>
+        </p:spPr>
+      </p:pic>
+      <p:sp>
+        <p:nvSpPr>
+          <p:cNvPr id="39" name="TextBox 38"/>
+          <p:cNvSpPr txBox="1"/>
+          <p:nvPr/>
+        </p:nvSpPr>
+        <p:spPr>
+          <a:xfrm>
+            <a:off x="2377440" y="3374136"/>
             <a:ext cx="1828800" cy="411480"/>
           </a:xfrm>
           <a:prstGeom prst="rect">
@@ -6240,13 +6312,13 @@
       </p:sp>
       <p:sp>
         <p:nvSpPr>
-          <p:cNvPr id="37" name="TextBox 36"/>
-          <p:cNvSpPr txBox="1"/>
-          <p:nvPr/>
-        </p:nvSpPr>
-        <p:spPr>
-          <a:xfrm>
-            <a:off x="2377440" y="3685032"/>
+          <p:cNvPr id="40" name="TextBox 39"/>
+          <p:cNvSpPr txBox="1"/>
+          <p:nvPr/>
+        </p:nvSpPr>
+        <p:spPr>
+          <a:xfrm>
+            <a:off x="2377440" y="3739896"/>
             <a:ext cx="1828800" cy="274320"/>
           </a:xfrm>
           <a:prstGeom prst="rect">
@@ -6275,13 +6347,13 @@
       </p:sp>
       <p:sp>
         <p:nvSpPr>
-          <p:cNvPr id="38" name="Oval 37"/>
+          <p:cNvPr id="41" name="Oval 40"/>
           <p:cNvSpPr/>
           <p:nvPr/>
         </p:nvSpPr>
         <p:spPr>
           <a:xfrm>
-            <a:off x="2377440" y="4050792"/>
+            <a:off x="2377440" y="4105656"/>
             <a:ext cx="201168" cy="201168"/>
           </a:xfrm>
           <a:prstGeom prst="ellipse">
@@ -6318,13 +6390,13 @@
       </p:sp>
       <p:sp>
         <p:nvSpPr>
-          <p:cNvPr id="39" name="Oval 38"/>
+          <p:cNvPr id="42" name="Oval 41"/>
           <p:cNvSpPr/>
           <p:nvPr/>
         </p:nvSpPr>
         <p:spPr>
           <a:xfrm>
-            <a:off x="2633472" y="4050792"/>
+            <a:off x="2633472" y="4105656"/>
             <a:ext cx="201168" cy="201168"/>
           </a:xfrm>
           <a:prstGeom prst="ellipse">
@@ -6361,13 +6433,13 @@
       </p:sp>
       <p:sp>
         <p:nvSpPr>
-          <p:cNvPr id="40" name="Oval 39"/>
+          <p:cNvPr id="43" name="Oval 42"/>
           <p:cNvSpPr/>
           <p:nvPr/>
         </p:nvSpPr>
         <p:spPr>
           <a:xfrm>
-            <a:off x="2889504" y="4050792"/>
+            <a:off x="2889504" y="4105656"/>
             <a:ext cx="201168" cy="201168"/>
           </a:xfrm>
           <a:prstGeom prst="ellipse">
@@ -6404,13 +6476,13 @@
       </p:sp>
       <p:sp>
         <p:nvSpPr>
-          <p:cNvPr id="41" name="Oval 40"/>
+          <p:cNvPr id="44" name="Oval 43"/>
           <p:cNvSpPr/>
           <p:nvPr/>
         </p:nvSpPr>
         <p:spPr>
           <a:xfrm>
-            <a:off x="3145536" y="4050792"/>
+            <a:off x="3145536" y="4105656"/>
             <a:ext cx="201168" cy="201168"/>
           </a:xfrm>
           <a:prstGeom prst="ellipse">
@@ -6447,13 +6519,13 @@
       </p:sp>
       <p:sp>
         <p:nvSpPr>
-          <p:cNvPr id="42" name="TextBox 41"/>
-          <p:cNvSpPr txBox="1"/>
-          <p:nvPr/>
-        </p:nvSpPr>
-        <p:spPr>
-          <a:xfrm>
-            <a:off x="4389120" y="3319272"/>
+          <p:cNvPr id="45" name="TextBox 44"/>
+          <p:cNvSpPr txBox="1"/>
+          <p:nvPr/>
+        </p:nvSpPr>
+        <p:spPr>
+          <a:xfrm>
+            <a:off x="4389120" y="3374136"/>
             <a:ext cx="2286000" cy="320040"/>
           </a:xfrm>
           <a:prstGeom prst="rect">
@@ -6482,14 +6554,14 @@
       </p:sp>
       <p:sp>
         <p:nvSpPr>
-          <p:cNvPr id="43" name="TextBox 42"/>
-          <p:cNvSpPr txBox="1"/>
-          <p:nvPr/>
-        </p:nvSpPr>
-        <p:spPr>
-          <a:xfrm>
-            <a:off x="4389120" y="3639312"/>
-            <a:ext cx="7406640" cy="777240"/>
+          <p:cNvPr id="46" name="TextBox 45"/>
+          <p:cNvSpPr txBox="1"/>
+          <p:nvPr/>
+        </p:nvSpPr>
+        <p:spPr>
+          <a:xfrm>
+            <a:off x="4389120" y="3694176"/>
+            <a:ext cx="4754880" cy="868680"/>
           </a:xfrm>
           <a:prstGeom prst="rect">
             <a:avLst/>
@@ -6518,14 +6590,14 @@
       </p:sp>
       <p:sp>
         <p:nvSpPr>
-          <p:cNvPr id="44" name="Rectangle 43"/>
+          <p:cNvPr id="47" name="Rectangle 46"/>
           <p:cNvSpPr/>
           <p:nvPr/>
         </p:nvSpPr>
         <p:spPr>
           <a:xfrm>
-            <a:off x="2194560" y="4690872"/>
-            <a:ext cx="9784080" cy="1417320"/>
+            <a:off x="2194560" y="4773168"/>
+            <a:ext cx="9784080" cy="1481328"/>
           </a:xfrm>
           <a:prstGeom prst="rect">
             <a:avLst/>
@@ -6561,14 +6633,14 @@
       </p:sp>
       <p:sp>
         <p:nvSpPr>
-          <p:cNvPr id="45" name="Rectangle 44"/>
+          <p:cNvPr id="48" name="Rectangle 47"/>
           <p:cNvSpPr/>
           <p:nvPr/>
         </p:nvSpPr>
         <p:spPr>
           <a:xfrm>
-            <a:off x="2194560" y="4690872"/>
-            <a:ext cx="73152" cy="1417320"/>
+            <a:off x="2194560" y="4773168"/>
+            <a:ext cx="73152" cy="1481328"/>
           </a:xfrm>
           <a:prstGeom prst="rect">
             <a:avLst/>
@@ -6602,15 +6674,39 @@
           </a:p>
         </p:txBody>
       </p:sp>
-      <p:sp>
-        <p:nvSpPr>
-          <p:cNvPr id="46" name="TextBox 45"/>
-          <p:cNvSpPr txBox="1"/>
-          <p:nvPr/>
-        </p:nvSpPr>
-        <p:spPr>
-          <a:xfrm>
-            <a:off x="2377440" y="4828032"/>
+      <p:pic>
+        <p:nvPicPr>
+          <p:cNvPr id="49" name="Picture 48" descr="liangzhu.jpg"/>
+          <p:cNvPicPr>
+            <a:picLocks noChangeAspect="1"/>
+          </p:cNvPicPr>
+          <p:nvPr/>
+        </p:nvPicPr>
+        <p:blipFill>
+          <a:blip r:embed="rId5"/>
+          <a:stretch>
+            <a:fillRect/>
+          </a:stretch>
+        </p:blipFill>
+        <p:spPr>
+          <a:xfrm>
+            <a:off x="9308592" y="4846320"/>
+            <a:ext cx="2596896" cy="1335024"/>
+          </a:xfrm>
+          <a:prstGeom prst="rect">
+            <a:avLst/>
+          </a:prstGeom>
+        </p:spPr>
+      </p:pic>
+      <p:sp>
+        <p:nvSpPr>
+          <p:cNvPr id="50" name="TextBox 49"/>
+          <p:cNvSpPr txBox="1"/>
+          <p:nvPr/>
+        </p:nvSpPr>
+        <p:spPr>
+          <a:xfrm>
+            <a:off x="2377440" y="4910328"/>
             <a:ext cx="1828800" cy="411480"/>
           </a:xfrm>
           <a:prstGeom prst="rect">
@@ -6639,13 +6735,13 @@
       </p:sp>
       <p:sp>
         <p:nvSpPr>
-          <p:cNvPr id="47" name="TextBox 46"/>
-          <p:cNvSpPr txBox="1"/>
-          <p:nvPr/>
-        </p:nvSpPr>
-        <p:spPr>
-          <a:xfrm>
-            <a:off x="2377440" y="5193792"/>
+          <p:cNvPr id="51" name="TextBox 50"/>
+          <p:cNvSpPr txBox="1"/>
+          <p:nvPr/>
+        </p:nvSpPr>
+        <p:spPr>
+          <a:xfrm>
+            <a:off x="2377440" y="5276088"/>
             <a:ext cx="1828800" cy="274320"/>
           </a:xfrm>
           <a:prstGeom prst="rect">
@@ -6674,13 +6770,13 @@
       </p:sp>
       <p:sp>
         <p:nvSpPr>
-          <p:cNvPr id="48" name="Oval 47"/>
+          <p:cNvPr id="52" name="Oval 51"/>
           <p:cNvSpPr/>
           <p:nvPr/>
         </p:nvSpPr>
         <p:spPr>
           <a:xfrm>
-            <a:off x="2377440" y="5559552"/>
+            <a:off x="2377440" y="5641848"/>
             <a:ext cx="201168" cy="201168"/>
           </a:xfrm>
           <a:prstGeom prst="ellipse">
@@ -6717,13 +6813,13 @@
       </p:sp>
       <p:sp>
         <p:nvSpPr>
-          <p:cNvPr id="49" name="Oval 48"/>
+          <p:cNvPr id="53" name="Oval 52"/>
           <p:cNvSpPr/>
           <p:nvPr/>
         </p:nvSpPr>
         <p:spPr>
           <a:xfrm>
-            <a:off x="2633472" y="5559552"/>
+            <a:off x="2633472" y="5641848"/>
             <a:ext cx="201168" cy="201168"/>
           </a:xfrm>
           <a:prstGeom prst="ellipse">
@@ -6760,13 +6856,13 @@
       </p:sp>
       <p:sp>
         <p:nvSpPr>
-          <p:cNvPr id="50" name="Oval 49"/>
+          <p:cNvPr id="54" name="Oval 53"/>
           <p:cNvSpPr/>
           <p:nvPr/>
         </p:nvSpPr>
         <p:spPr>
           <a:xfrm>
-            <a:off x="2889504" y="5559552"/>
+            <a:off x="2889504" y="5641848"/>
             <a:ext cx="201168" cy="201168"/>
           </a:xfrm>
           <a:prstGeom prst="ellipse">
@@ -6803,13 +6899,13 @@
       </p:sp>
       <p:sp>
         <p:nvSpPr>
-          <p:cNvPr id="51" name="Oval 50"/>
+          <p:cNvPr id="55" name="Oval 54"/>
           <p:cNvSpPr/>
           <p:nvPr/>
         </p:nvSpPr>
         <p:spPr>
           <a:xfrm>
-            <a:off x="3145536" y="5559552"/>
+            <a:off x="3145536" y="5641848"/>
             <a:ext cx="201168" cy="201168"/>
           </a:xfrm>
           <a:prstGeom prst="ellipse">
@@ -6846,13 +6942,13 @@
       </p:sp>
       <p:sp>
         <p:nvSpPr>
-          <p:cNvPr id="52" name="TextBox 51"/>
-          <p:cNvSpPr txBox="1"/>
-          <p:nvPr/>
-        </p:nvSpPr>
-        <p:spPr>
-          <a:xfrm>
-            <a:off x="4389120" y="4828032"/>
+          <p:cNvPr id="56" name="TextBox 55"/>
+          <p:cNvSpPr txBox="1"/>
+          <p:nvPr/>
+        </p:nvSpPr>
+        <p:spPr>
+          <a:xfrm>
+            <a:off x="4389120" y="4910328"/>
             <a:ext cx="2286000" cy="320040"/>
           </a:xfrm>
           <a:prstGeom prst="rect">
@@ -6881,14 +6977,14 @@
       </p:sp>
       <p:sp>
         <p:nvSpPr>
-          <p:cNvPr id="53" name="TextBox 52"/>
-          <p:cNvSpPr txBox="1"/>
-          <p:nvPr/>
-        </p:nvSpPr>
-        <p:spPr>
-          <a:xfrm>
-            <a:off x="4389120" y="5148072"/>
-            <a:ext cx="7406640" cy="777240"/>
+          <p:cNvPr id="57" name="TextBox 56"/>
+          <p:cNvSpPr txBox="1"/>
+          <p:nvPr/>
+        </p:nvSpPr>
+        <p:spPr>
+          <a:xfrm>
+            <a:off x="4389120" y="5230368"/>
+            <a:ext cx="4754880" cy="868680"/>
           </a:xfrm>
           <a:prstGeom prst="rect">
             <a:avLst/>
@@ -11318,33 +11414,57 @@
           </a:p>
         </p:txBody>
       </p:sp>
-      <p:sp>
-        <p:nvSpPr>
-          <p:cNvPr id="9" name="TextBox 8"/>
-          <p:cNvSpPr txBox="1"/>
-          <p:nvPr/>
-        </p:nvSpPr>
-        <p:spPr>
-          <a:xfrm>
-            <a:off x="237744" y="1399032"/>
-            <a:ext cx="548640" cy="457200"/>
-          </a:xfrm>
-          <a:prstGeom prst="rect">
-            <a:avLst/>
-          </a:prstGeom>
-          <a:noFill/>
-        </p:spPr>
-        <p:txBody>
-          <a:bodyPr wrap="square">
-            <a:spAutoFit/>
-          </a:bodyPr>
-          <a:lstStyle/>
-          <a:p>
-            <a:pPr algn="l"/>
-            <a:r>
-              <a:rPr sz="2800" b="1" i="0">
-                <a:solidFill>
-                  <a:srgbClr val="D8D3CC"/>
+      <p:pic>
+        <p:nvPicPr>
+          <p:cNvPr id="9" name="Picture 8" descr="shaanxi.jpg"/>
+          <p:cNvPicPr>
+            <a:picLocks noChangeAspect="1"/>
+          </p:cNvPicPr>
+          <p:nvPr/>
+        </p:nvPicPr>
+        <p:blipFill>
+          <a:blip r:embed="rId2"/>
+          <a:stretch>
+            <a:fillRect/>
+          </a:stretch>
+        </p:blipFill>
+        <p:spPr>
+          <a:xfrm>
+            <a:off x="109728" y="1316736"/>
+            <a:ext cx="3822192" cy="914400"/>
+          </a:xfrm>
+          <a:prstGeom prst="rect">
+            <a:avLst/>
+          </a:prstGeom>
+        </p:spPr>
+      </p:pic>
+      <p:sp>
+        <p:nvSpPr>
+          <p:cNvPr id="10" name="TextBox 9"/>
+          <p:cNvSpPr txBox="1"/>
+          <p:nvPr/>
+        </p:nvSpPr>
+        <p:spPr>
+          <a:xfrm>
+            <a:off x="164592" y="1335024"/>
+            <a:ext cx="502920" cy="411480"/>
+          </a:xfrm>
+          <a:prstGeom prst="rect">
+            <a:avLst/>
+          </a:prstGeom>
+          <a:noFill/>
+        </p:spPr>
+        <p:txBody>
+          <a:bodyPr wrap="square">
+            <a:spAutoFit/>
+          </a:bodyPr>
+          <a:lstStyle/>
+          <a:p>
+            <a:pPr algn="l"/>
+            <a:r>
+              <a:rPr sz="2200" b="1" i="0">
+                <a:solidFill>
+                  <a:srgbClr val="FFFFFF"/>
                 </a:solidFill>
                 <a:latin typeface="PingFang SC"/>
               </a:rPr>
@@ -11355,14 +11475,14 @@
       </p:sp>
       <p:sp>
         <p:nvSpPr>
-          <p:cNvPr id="10" name="Oval 9"/>
+          <p:cNvPr id="11" name="Oval 10"/>
           <p:cNvSpPr/>
           <p:nvPr/>
         </p:nvSpPr>
         <p:spPr>
           <a:xfrm>
-            <a:off x="3483864" y="1463040"/>
-            <a:ext cx="256032" cy="256032"/>
+            <a:off x="3529584" y="1371600"/>
+            <a:ext cx="237744" cy="237744"/>
           </a:xfrm>
           <a:prstGeom prst="ellipse">
             <a:avLst/>
@@ -11398,29 +11518,29 @@
       </p:sp>
       <p:sp>
         <p:nvSpPr>
-          <p:cNvPr id="11" name="TextBox 10"/>
-          <p:cNvSpPr txBox="1"/>
-          <p:nvPr/>
-        </p:nvSpPr>
-        <p:spPr>
-          <a:xfrm>
-            <a:off x="237744" y="1883664"/>
-            <a:ext cx="3566160" cy="411480"/>
-          </a:xfrm>
-          <a:prstGeom prst="rect">
-            <a:avLst/>
-          </a:prstGeom>
-          <a:noFill/>
-        </p:spPr>
-        <p:txBody>
-          <a:bodyPr wrap="square">
-            <a:spAutoFit/>
-          </a:bodyPr>
-          <a:lstStyle/>
-          <a:p>
-            <a:pPr algn="l"/>
-            <a:r>
-              <a:rPr sz="1700" b="1" i="0">
+          <p:cNvPr id="12" name="TextBox 11"/>
+          <p:cNvSpPr txBox="1"/>
+          <p:nvPr/>
+        </p:nvSpPr>
+        <p:spPr>
+          <a:xfrm>
+            <a:off x="219456" y="2267712"/>
+            <a:ext cx="3602736" cy="384048"/>
+          </a:xfrm>
+          <a:prstGeom prst="rect">
+            <a:avLst/>
+          </a:prstGeom>
+          <a:noFill/>
+        </p:spPr>
+        <p:txBody>
+          <a:bodyPr wrap="square">
+            <a:spAutoFit/>
+          </a:bodyPr>
+          <a:lstStyle/>
+          <a:p>
+            <a:pPr algn="l"/>
+            <a:r>
+              <a:rPr sz="1500" b="1" i="0">
                 <a:solidFill>
                   <a:srgbClr val="1E1A17"/>
                 </a:solidFill>
@@ -11433,29 +11553,29 @@
       </p:sp>
       <p:sp>
         <p:nvSpPr>
-          <p:cNvPr id="12" name="TextBox 11"/>
-          <p:cNvSpPr txBox="1"/>
-          <p:nvPr/>
-        </p:nvSpPr>
-        <p:spPr>
-          <a:xfrm>
-            <a:off x="237744" y="2267712"/>
-            <a:ext cx="3566160" cy="274320"/>
-          </a:xfrm>
-          <a:prstGeom prst="rect">
-            <a:avLst/>
-          </a:prstGeom>
-          <a:noFill/>
-        </p:spPr>
-        <p:txBody>
-          <a:bodyPr wrap="square">
-            <a:spAutoFit/>
-          </a:bodyPr>
-          <a:lstStyle/>
-          <a:p>
-            <a:pPr algn="l"/>
-            <a:r>
-              <a:rPr sz="900" b="0" i="0">
+          <p:cNvPr id="13" name="TextBox 12"/>
+          <p:cNvSpPr txBox="1"/>
+          <p:nvPr/>
+        </p:nvSpPr>
+        <p:spPr>
+          <a:xfrm>
+            <a:off x="219456" y="2633472"/>
+            <a:ext cx="3602736" cy="228600"/>
+          </a:xfrm>
+          <a:prstGeom prst="rect">
+            <a:avLst/>
+          </a:prstGeom>
+          <a:noFill/>
+        </p:spPr>
+        <p:txBody>
+          <a:bodyPr wrap="square">
+            <a:spAutoFit/>
+          </a:bodyPr>
+          <a:lstStyle/>
+          <a:p>
+            <a:pPr algn="l"/>
+            <a:r>
+              <a:rPr sz="800" b="0" i="0">
                 <a:solidFill>
                   <a:srgbClr val="8A857E"/>
                 </a:solidFill>
@@ -11468,29 +11588,29 @@
       </p:sp>
       <p:sp>
         <p:nvSpPr>
-          <p:cNvPr id="13" name="TextBox 12"/>
-          <p:cNvSpPr txBox="1"/>
-          <p:nvPr/>
-        </p:nvSpPr>
-        <p:spPr>
-          <a:xfrm>
-            <a:off x="237744" y="2587752"/>
-            <a:ext cx="3566160" cy="301752"/>
-          </a:xfrm>
-          <a:prstGeom prst="rect">
-            <a:avLst/>
-          </a:prstGeom>
-          <a:noFill/>
-        </p:spPr>
-        <p:txBody>
-          <a:bodyPr wrap="square">
-            <a:spAutoFit/>
-          </a:bodyPr>
-          <a:lstStyle/>
-          <a:p>
-            <a:pPr algn="l"/>
-            <a:r>
-              <a:rPr sz="1000" b="0" i="0">
+          <p:cNvPr id="14" name="TextBox 13"/>
+          <p:cNvSpPr txBox="1"/>
+          <p:nvPr/>
+        </p:nvSpPr>
+        <p:spPr>
+          <a:xfrm>
+            <a:off x="219456" y="2889504"/>
+            <a:ext cx="3602736" cy="274320"/>
+          </a:xfrm>
+          <a:prstGeom prst="rect">
+            <a:avLst/>
+          </a:prstGeom>
+          <a:noFill/>
+        </p:spPr>
+        <p:txBody>
+          <a:bodyPr wrap="square">
+            <a:spAutoFit/>
+          </a:bodyPr>
+          <a:lstStyle/>
+          <a:p>
+            <a:pPr algn="l"/>
+            <a:r>
+              <a:rPr sz="950" b="0" i="0">
                 <a:solidFill>
                   <a:srgbClr val="8A857E"/>
                 </a:solidFill>
@@ -11503,29 +11623,29 @@
       </p:sp>
       <p:sp>
         <p:nvSpPr>
-          <p:cNvPr id="14" name="TextBox 13"/>
-          <p:cNvSpPr txBox="1"/>
-          <p:nvPr/>
-        </p:nvSpPr>
-        <p:spPr>
-          <a:xfrm>
-            <a:off x="237744" y="2926080"/>
-            <a:ext cx="3566160" cy="301752"/>
-          </a:xfrm>
-          <a:prstGeom prst="rect">
-            <a:avLst/>
-          </a:prstGeom>
-          <a:noFill/>
-        </p:spPr>
-        <p:txBody>
-          <a:bodyPr wrap="square">
-            <a:spAutoFit/>
-          </a:bodyPr>
-          <a:lstStyle/>
-          <a:p>
-            <a:pPr algn="l"/>
-            <a:r>
-              <a:rPr sz="1000" b="0" i="0">
+          <p:cNvPr id="15" name="TextBox 14"/>
+          <p:cNvSpPr txBox="1"/>
+          <p:nvPr/>
+        </p:nvSpPr>
+        <p:spPr>
+          <a:xfrm>
+            <a:off x="219456" y="3200400"/>
+            <a:ext cx="3602736" cy="274320"/>
+          </a:xfrm>
+          <a:prstGeom prst="rect">
+            <a:avLst/>
+          </a:prstGeom>
+          <a:noFill/>
+        </p:spPr>
+        <p:txBody>
+          <a:bodyPr wrap="square">
+            <a:spAutoFit/>
+          </a:bodyPr>
+          <a:lstStyle/>
+          <a:p>
+            <a:pPr algn="l"/>
+            <a:r>
+              <a:rPr sz="950" b="0" i="0">
                 <a:solidFill>
                   <a:srgbClr val="8A857E"/>
                 </a:solidFill>
@@ -11538,29 +11658,29 @@
       </p:sp>
       <p:sp>
         <p:nvSpPr>
-          <p:cNvPr id="15" name="TextBox 14"/>
-          <p:cNvSpPr txBox="1"/>
-          <p:nvPr/>
-        </p:nvSpPr>
-        <p:spPr>
-          <a:xfrm>
-            <a:off x="237744" y="3264408"/>
-            <a:ext cx="3566160" cy="301752"/>
-          </a:xfrm>
-          <a:prstGeom prst="rect">
-            <a:avLst/>
-          </a:prstGeom>
-          <a:noFill/>
-        </p:spPr>
-        <p:txBody>
-          <a:bodyPr wrap="square">
-            <a:spAutoFit/>
-          </a:bodyPr>
-          <a:lstStyle/>
-          <a:p>
-            <a:pPr algn="l"/>
-            <a:r>
-              <a:rPr sz="1000" b="0" i="0">
+          <p:cNvPr id="16" name="TextBox 15"/>
+          <p:cNvSpPr txBox="1"/>
+          <p:nvPr/>
+        </p:nvSpPr>
+        <p:spPr>
+          <a:xfrm>
+            <a:off x="219456" y="3511296"/>
+            <a:ext cx="3602736" cy="274320"/>
+          </a:xfrm>
+          <a:prstGeom prst="rect">
+            <a:avLst/>
+          </a:prstGeom>
+          <a:noFill/>
+        </p:spPr>
+        <p:txBody>
+          <a:bodyPr wrap="square">
+            <a:spAutoFit/>
+          </a:bodyPr>
+          <a:lstStyle/>
+          <a:p>
+            <a:pPr algn="l"/>
+            <a:r>
+              <a:rPr sz="950" b="0" i="0">
                 <a:solidFill>
                   <a:srgbClr val="8A857E"/>
                 </a:solidFill>
@@ -11573,7 +11693,7 @@
       </p:sp>
       <p:sp>
         <p:nvSpPr>
-          <p:cNvPr id="16" name="Rectangle 15"/>
+          <p:cNvPr id="17" name="Rectangle 16"/>
           <p:cNvSpPr/>
           <p:nvPr/>
         </p:nvSpPr>
@@ -11614,33 +11734,57 @@
           </a:p>
         </p:txBody>
       </p:sp>
-      <p:sp>
-        <p:nvSpPr>
-          <p:cNvPr id="17" name="TextBox 16"/>
-          <p:cNvSpPr txBox="1"/>
-          <p:nvPr/>
-        </p:nvSpPr>
-        <p:spPr>
-          <a:xfrm>
-            <a:off x="4261104" y="1399032"/>
-            <a:ext cx="548640" cy="457200"/>
-          </a:xfrm>
-          <a:prstGeom prst="rect">
-            <a:avLst/>
-          </a:prstGeom>
-          <a:noFill/>
-        </p:spPr>
-        <p:txBody>
-          <a:bodyPr wrap="square">
-            <a:spAutoFit/>
-          </a:bodyPr>
-          <a:lstStyle/>
-          <a:p>
-            <a:pPr algn="l"/>
-            <a:r>
-              <a:rPr sz="2800" b="1" i="0">
-                <a:solidFill>
-                  <a:srgbClr val="D8D3CC"/>
+      <p:pic>
+        <p:nvPicPr>
+          <p:cNvPr id="18" name="Picture 17" descr="terracotta.jpg"/>
+          <p:cNvPicPr>
+            <a:picLocks noChangeAspect="1"/>
+          </p:cNvPicPr>
+          <p:nvPr/>
+        </p:nvPicPr>
+        <p:blipFill>
+          <a:blip r:embed="rId3"/>
+          <a:stretch>
+            <a:fillRect/>
+          </a:stretch>
+        </p:blipFill>
+        <p:spPr>
+          <a:xfrm>
+            <a:off x="4133088" y="1316736"/>
+            <a:ext cx="3822192" cy="914400"/>
+          </a:xfrm>
+          <a:prstGeom prst="rect">
+            <a:avLst/>
+          </a:prstGeom>
+        </p:spPr>
+      </p:pic>
+      <p:sp>
+        <p:nvSpPr>
+          <p:cNvPr id="19" name="TextBox 18"/>
+          <p:cNvSpPr txBox="1"/>
+          <p:nvPr/>
+        </p:nvSpPr>
+        <p:spPr>
+          <a:xfrm>
+            <a:off x="4187952" y="1335024"/>
+            <a:ext cx="502920" cy="411480"/>
+          </a:xfrm>
+          <a:prstGeom prst="rect">
+            <a:avLst/>
+          </a:prstGeom>
+          <a:noFill/>
+        </p:spPr>
+        <p:txBody>
+          <a:bodyPr wrap="square">
+            <a:spAutoFit/>
+          </a:bodyPr>
+          <a:lstStyle/>
+          <a:p>
+            <a:pPr algn="l"/>
+            <a:r>
+              <a:rPr sz="2200" b="1" i="0">
+                <a:solidFill>
+                  <a:srgbClr val="FFFFFF"/>
                 </a:solidFill>
                 <a:latin typeface="PingFang SC"/>
               </a:rPr>
@@ -11651,14 +11795,14 @@
       </p:sp>
       <p:sp>
         <p:nvSpPr>
-          <p:cNvPr id="18" name="Oval 17"/>
+          <p:cNvPr id="20" name="Oval 19"/>
           <p:cNvSpPr/>
           <p:nvPr/>
         </p:nvSpPr>
         <p:spPr>
           <a:xfrm>
-            <a:off x="7507224" y="1463040"/>
-            <a:ext cx="256032" cy="256032"/>
+            <a:off x="7552944" y="1371600"/>
+            <a:ext cx="237744" cy="237744"/>
           </a:xfrm>
           <a:prstGeom prst="ellipse">
             <a:avLst/>
@@ -11694,29 +11838,29 @@
       </p:sp>
       <p:sp>
         <p:nvSpPr>
-          <p:cNvPr id="19" name="TextBox 18"/>
-          <p:cNvSpPr txBox="1"/>
-          <p:nvPr/>
-        </p:nvSpPr>
-        <p:spPr>
-          <a:xfrm>
-            <a:off x="4261104" y="1883664"/>
-            <a:ext cx="3566160" cy="411480"/>
-          </a:xfrm>
-          <a:prstGeom prst="rect">
-            <a:avLst/>
-          </a:prstGeom>
-          <a:noFill/>
-        </p:spPr>
-        <p:txBody>
-          <a:bodyPr wrap="square">
-            <a:spAutoFit/>
-          </a:bodyPr>
-          <a:lstStyle/>
-          <a:p>
-            <a:pPr algn="l"/>
-            <a:r>
-              <a:rPr sz="1700" b="1" i="0">
+          <p:cNvPr id="21" name="TextBox 20"/>
+          <p:cNvSpPr txBox="1"/>
+          <p:nvPr/>
+        </p:nvSpPr>
+        <p:spPr>
+          <a:xfrm>
+            <a:off x="4242816" y="2267712"/>
+            <a:ext cx="3602736" cy="384048"/>
+          </a:xfrm>
+          <a:prstGeom prst="rect">
+            <a:avLst/>
+          </a:prstGeom>
+          <a:noFill/>
+        </p:spPr>
+        <p:txBody>
+          <a:bodyPr wrap="square">
+            <a:spAutoFit/>
+          </a:bodyPr>
+          <a:lstStyle/>
+          <a:p>
+            <a:pPr algn="l"/>
+            <a:r>
+              <a:rPr sz="1500" b="1" i="0">
                 <a:solidFill>
                   <a:srgbClr val="1E1A17"/>
                 </a:solidFill>
@@ -11729,29 +11873,29 @@
       </p:sp>
       <p:sp>
         <p:nvSpPr>
-          <p:cNvPr id="20" name="TextBox 19"/>
-          <p:cNvSpPr txBox="1"/>
-          <p:nvPr/>
-        </p:nvSpPr>
-        <p:spPr>
-          <a:xfrm>
-            <a:off x="4261104" y="2267712"/>
-            <a:ext cx="3566160" cy="274320"/>
-          </a:xfrm>
-          <a:prstGeom prst="rect">
-            <a:avLst/>
-          </a:prstGeom>
-          <a:noFill/>
-        </p:spPr>
-        <p:txBody>
-          <a:bodyPr wrap="square">
-            <a:spAutoFit/>
-          </a:bodyPr>
-          <a:lstStyle/>
-          <a:p>
-            <a:pPr algn="l"/>
-            <a:r>
-              <a:rPr sz="900" b="0" i="0">
+          <p:cNvPr id="22" name="TextBox 21"/>
+          <p:cNvSpPr txBox="1"/>
+          <p:nvPr/>
+        </p:nvSpPr>
+        <p:spPr>
+          <a:xfrm>
+            <a:off x="4242816" y="2633472"/>
+            <a:ext cx="3602736" cy="228600"/>
+          </a:xfrm>
+          <a:prstGeom prst="rect">
+            <a:avLst/>
+          </a:prstGeom>
+          <a:noFill/>
+        </p:spPr>
+        <p:txBody>
+          <a:bodyPr wrap="square">
+            <a:spAutoFit/>
+          </a:bodyPr>
+          <a:lstStyle/>
+          <a:p>
+            <a:pPr algn="l"/>
+            <a:r>
+              <a:rPr sz="800" b="0" i="0">
                 <a:solidFill>
                   <a:srgbClr val="8A857E"/>
                 </a:solidFill>
@@ -11764,29 +11908,29 @@
       </p:sp>
       <p:sp>
         <p:nvSpPr>
-          <p:cNvPr id="21" name="TextBox 20"/>
-          <p:cNvSpPr txBox="1"/>
-          <p:nvPr/>
-        </p:nvSpPr>
-        <p:spPr>
-          <a:xfrm>
-            <a:off x="4261104" y="2587752"/>
-            <a:ext cx="3566160" cy="301752"/>
-          </a:xfrm>
-          <a:prstGeom prst="rect">
-            <a:avLst/>
-          </a:prstGeom>
-          <a:noFill/>
-        </p:spPr>
-        <p:txBody>
-          <a:bodyPr wrap="square">
-            <a:spAutoFit/>
-          </a:bodyPr>
-          <a:lstStyle/>
-          <a:p>
-            <a:pPr algn="l"/>
-            <a:r>
-              <a:rPr sz="1000" b="0" i="0">
+          <p:cNvPr id="23" name="TextBox 22"/>
+          <p:cNvSpPr txBox="1"/>
+          <p:nvPr/>
+        </p:nvSpPr>
+        <p:spPr>
+          <a:xfrm>
+            <a:off x="4242816" y="2889504"/>
+            <a:ext cx="3602736" cy="274320"/>
+          </a:xfrm>
+          <a:prstGeom prst="rect">
+            <a:avLst/>
+          </a:prstGeom>
+          <a:noFill/>
+        </p:spPr>
+        <p:txBody>
+          <a:bodyPr wrap="square">
+            <a:spAutoFit/>
+          </a:bodyPr>
+          <a:lstStyle/>
+          <a:p>
+            <a:pPr algn="l"/>
+            <a:r>
+              <a:rPr sz="950" b="0" i="0">
                 <a:solidFill>
                   <a:srgbClr val="8A857E"/>
                 </a:solidFill>
@@ -11799,29 +11943,29 @@
       </p:sp>
       <p:sp>
         <p:nvSpPr>
-          <p:cNvPr id="22" name="TextBox 21"/>
-          <p:cNvSpPr txBox="1"/>
-          <p:nvPr/>
-        </p:nvSpPr>
-        <p:spPr>
-          <a:xfrm>
-            <a:off x="4261104" y="2926080"/>
-            <a:ext cx="3566160" cy="301752"/>
-          </a:xfrm>
-          <a:prstGeom prst="rect">
-            <a:avLst/>
-          </a:prstGeom>
-          <a:noFill/>
-        </p:spPr>
-        <p:txBody>
-          <a:bodyPr wrap="square">
-            <a:spAutoFit/>
-          </a:bodyPr>
-          <a:lstStyle/>
-          <a:p>
-            <a:pPr algn="l"/>
-            <a:r>
-              <a:rPr sz="1000" b="0" i="0">
+          <p:cNvPr id="24" name="TextBox 23"/>
+          <p:cNvSpPr txBox="1"/>
+          <p:nvPr/>
+        </p:nvSpPr>
+        <p:spPr>
+          <a:xfrm>
+            <a:off x="4242816" y="3200400"/>
+            <a:ext cx="3602736" cy="274320"/>
+          </a:xfrm>
+          <a:prstGeom prst="rect">
+            <a:avLst/>
+          </a:prstGeom>
+          <a:noFill/>
+        </p:spPr>
+        <p:txBody>
+          <a:bodyPr wrap="square">
+            <a:spAutoFit/>
+          </a:bodyPr>
+          <a:lstStyle/>
+          <a:p>
+            <a:pPr algn="l"/>
+            <a:r>
+              <a:rPr sz="950" b="0" i="0">
                 <a:solidFill>
                   <a:srgbClr val="8A857E"/>
                 </a:solidFill>
@@ -11834,29 +11978,29 @@
       </p:sp>
       <p:sp>
         <p:nvSpPr>
-          <p:cNvPr id="23" name="TextBox 22"/>
-          <p:cNvSpPr txBox="1"/>
-          <p:nvPr/>
-        </p:nvSpPr>
-        <p:spPr>
-          <a:xfrm>
-            <a:off x="4261104" y="3264408"/>
-            <a:ext cx="3566160" cy="301752"/>
-          </a:xfrm>
-          <a:prstGeom prst="rect">
-            <a:avLst/>
-          </a:prstGeom>
-          <a:noFill/>
-        </p:spPr>
-        <p:txBody>
-          <a:bodyPr wrap="square">
-            <a:spAutoFit/>
-          </a:bodyPr>
-          <a:lstStyle/>
-          <a:p>
-            <a:pPr algn="l"/>
-            <a:r>
-              <a:rPr sz="1000" b="0" i="0">
+          <p:cNvPr id="25" name="TextBox 24"/>
+          <p:cNvSpPr txBox="1"/>
+          <p:nvPr/>
+        </p:nvSpPr>
+        <p:spPr>
+          <a:xfrm>
+            <a:off x="4242816" y="3511296"/>
+            <a:ext cx="3602736" cy="274320"/>
+          </a:xfrm>
+          <a:prstGeom prst="rect">
+            <a:avLst/>
+          </a:prstGeom>
+          <a:noFill/>
+        </p:spPr>
+        <p:txBody>
+          <a:bodyPr wrap="square">
+            <a:spAutoFit/>
+          </a:bodyPr>
+          <a:lstStyle/>
+          <a:p>
+            <a:pPr algn="l"/>
+            <a:r>
+              <a:rPr sz="950" b="0" i="0">
                 <a:solidFill>
                   <a:srgbClr val="8A857E"/>
                 </a:solidFill>
@@ -11869,7 +12013,7 @@
       </p:sp>
       <p:sp>
         <p:nvSpPr>
-          <p:cNvPr id="24" name="Rectangle 23"/>
+          <p:cNvPr id="26" name="Rectangle 25"/>
           <p:cNvSpPr/>
           <p:nvPr/>
         </p:nvSpPr>
@@ -11910,33 +12054,57 @@
           </a:p>
         </p:txBody>
       </p:sp>
-      <p:sp>
-        <p:nvSpPr>
-          <p:cNvPr id="25" name="TextBox 24"/>
-          <p:cNvSpPr txBox="1"/>
-          <p:nvPr/>
-        </p:nvSpPr>
-        <p:spPr>
-          <a:xfrm>
-            <a:off x="8284464" y="1399032"/>
-            <a:ext cx="548640" cy="457200"/>
-          </a:xfrm>
-          <a:prstGeom prst="rect">
-            <a:avLst/>
-          </a:prstGeom>
-          <a:noFill/>
-        </p:spPr>
-        <p:txBody>
-          <a:bodyPr wrap="square">
-            <a:spAutoFit/>
-          </a:bodyPr>
-          <a:lstStyle/>
-          <a:p>
-            <a:pPr algn="l"/>
-            <a:r>
-              <a:rPr sz="2800" b="1" i="0">
-                <a:solidFill>
-                  <a:srgbClr val="D8D3CC"/>
+      <p:pic>
+        <p:nvPicPr>
+          <p:cNvPr id="27" name="Picture 26" descr="xian_bwy.jpg"/>
+          <p:cNvPicPr>
+            <a:picLocks noChangeAspect="1"/>
+          </p:cNvPicPr>
+          <p:nvPr/>
+        </p:nvPicPr>
+        <p:blipFill>
+          <a:blip r:embed="rId4"/>
+          <a:stretch>
+            <a:fillRect/>
+          </a:stretch>
+        </p:blipFill>
+        <p:spPr>
+          <a:xfrm>
+            <a:off x="8156448" y="1316736"/>
+            <a:ext cx="3822192" cy="914400"/>
+          </a:xfrm>
+          <a:prstGeom prst="rect">
+            <a:avLst/>
+          </a:prstGeom>
+        </p:spPr>
+      </p:pic>
+      <p:sp>
+        <p:nvSpPr>
+          <p:cNvPr id="28" name="TextBox 27"/>
+          <p:cNvSpPr txBox="1"/>
+          <p:nvPr/>
+        </p:nvSpPr>
+        <p:spPr>
+          <a:xfrm>
+            <a:off x="8211312" y="1335024"/>
+            <a:ext cx="502920" cy="411480"/>
+          </a:xfrm>
+          <a:prstGeom prst="rect">
+            <a:avLst/>
+          </a:prstGeom>
+          <a:noFill/>
+        </p:spPr>
+        <p:txBody>
+          <a:bodyPr wrap="square">
+            <a:spAutoFit/>
+          </a:bodyPr>
+          <a:lstStyle/>
+          <a:p>
+            <a:pPr algn="l"/>
+            <a:r>
+              <a:rPr sz="2200" b="1" i="0">
+                <a:solidFill>
+                  <a:srgbClr val="FFFFFF"/>
                 </a:solidFill>
                 <a:latin typeface="PingFang SC"/>
               </a:rPr>
@@ -11947,14 +12115,14 @@
       </p:sp>
       <p:sp>
         <p:nvSpPr>
-          <p:cNvPr id="26" name="Oval 25"/>
+          <p:cNvPr id="29" name="Oval 28"/>
           <p:cNvSpPr/>
           <p:nvPr/>
         </p:nvSpPr>
         <p:spPr>
           <a:xfrm>
-            <a:off x="11530584" y="1463040"/>
-            <a:ext cx="256032" cy="256032"/>
+            <a:off x="11576304" y="1371600"/>
+            <a:ext cx="237744" cy="237744"/>
           </a:xfrm>
           <a:prstGeom prst="ellipse">
             <a:avLst/>
@@ -11990,29 +12158,29 @@
       </p:sp>
       <p:sp>
         <p:nvSpPr>
-          <p:cNvPr id="27" name="TextBox 26"/>
-          <p:cNvSpPr txBox="1"/>
-          <p:nvPr/>
-        </p:nvSpPr>
-        <p:spPr>
-          <a:xfrm>
-            <a:off x="8284464" y="1883664"/>
-            <a:ext cx="3566160" cy="411480"/>
-          </a:xfrm>
-          <a:prstGeom prst="rect">
-            <a:avLst/>
-          </a:prstGeom>
-          <a:noFill/>
-        </p:spPr>
-        <p:txBody>
-          <a:bodyPr wrap="square">
-            <a:spAutoFit/>
-          </a:bodyPr>
-          <a:lstStyle/>
-          <a:p>
-            <a:pPr algn="l"/>
-            <a:r>
-              <a:rPr sz="1700" b="1" i="0">
+          <p:cNvPr id="30" name="TextBox 29"/>
+          <p:cNvSpPr txBox="1"/>
+          <p:nvPr/>
+        </p:nvSpPr>
+        <p:spPr>
+          <a:xfrm>
+            <a:off x="8266176" y="2267712"/>
+            <a:ext cx="3602736" cy="384048"/>
+          </a:xfrm>
+          <a:prstGeom prst="rect">
+            <a:avLst/>
+          </a:prstGeom>
+          <a:noFill/>
+        </p:spPr>
+        <p:txBody>
+          <a:bodyPr wrap="square">
+            <a:spAutoFit/>
+          </a:bodyPr>
+          <a:lstStyle/>
+          <a:p>
+            <a:pPr algn="l"/>
+            <a:r>
+              <a:rPr sz="1500" b="1" i="0">
                 <a:solidFill>
                   <a:srgbClr val="1E1A17"/>
                 </a:solidFill>
@@ -12025,29 +12193,29 @@
       </p:sp>
       <p:sp>
         <p:nvSpPr>
-          <p:cNvPr id="28" name="TextBox 27"/>
-          <p:cNvSpPr txBox="1"/>
-          <p:nvPr/>
-        </p:nvSpPr>
-        <p:spPr>
-          <a:xfrm>
-            <a:off x="8284464" y="2267712"/>
-            <a:ext cx="3566160" cy="274320"/>
-          </a:xfrm>
-          <a:prstGeom prst="rect">
-            <a:avLst/>
-          </a:prstGeom>
-          <a:noFill/>
-        </p:spPr>
-        <p:txBody>
-          <a:bodyPr wrap="square">
-            <a:spAutoFit/>
-          </a:bodyPr>
-          <a:lstStyle/>
-          <a:p>
-            <a:pPr algn="l"/>
-            <a:r>
-              <a:rPr sz="900" b="0" i="0">
+          <p:cNvPr id="31" name="TextBox 30"/>
+          <p:cNvSpPr txBox="1"/>
+          <p:nvPr/>
+        </p:nvSpPr>
+        <p:spPr>
+          <a:xfrm>
+            <a:off x="8266176" y="2633472"/>
+            <a:ext cx="3602736" cy="228600"/>
+          </a:xfrm>
+          <a:prstGeom prst="rect">
+            <a:avLst/>
+          </a:prstGeom>
+          <a:noFill/>
+        </p:spPr>
+        <p:txBody>
+          <a:bodyPr wrap="square">
+            <a:spAutoFit/>
+          </a:bodyPr>
+          <a:lstStyle/>
+          <a:p>
+            <a:pPr algn="l"/>
+            <a:r>
+              <a:rPr sz="800" b="0" i="0">
                 <a:solidFill>
                   <a:srgbClr val="8A857E"/>
                 </a:solidFill>
@@ -12060,29 +12228,29 @@
       </p:sp>
       <p:sp>
         <p:nvSpPr>
-          <p:cNvPr id="29" name="TextBox 28"/>
-          <p:cNvSpPr txBox="1"/>
-          <p:nvPr/>
-        </p:nvSpPr>
-        <p:spPr>
-          <a:xfrm>
-            <a:off x="8284464" y="2587752"/>
-            <a:ext cx="3566160" cy="301752"/>
-          </a:xfrm>
-          <a:prstGeom prst="rect">
-            <a:avLst/>
-          </a:prstGeom>
-          <a:noFill/>
-        </p:spPr>
-        <p:txBody>
-          <a:bodyPr wrap="square">
-            <a:spAutoFit/>
-          </a:bodyPr>
-          <a:lstStyle/>
-          <a:p>
-            <a:pPr algn="l"/>
-            <a:r>
-              <a:rPr sz="1000" b="0" i="0">
+          <p:cNvPr id="32" name="TextBox 31"/>
+          <p:cNvSpPr txBox="1"/>
+          <p:nvPr/>
+        </p:nvSpPr>
+        <p:spPr>
+          <a:xfrm>
+            <a:off x="8266176" y="2889504"/>
+            <a:ext cx="3602736" cy="274320"/>
+          </a:xfrm>
+          <a:prstGeom prst="rect">
+            <a:avLst/>
+          </a:prstGeom>
+          <a:noFill/>
+        </p:spPr>
+        <p:txBody>
+          <a:bodyPr wrap="square">
+            <a:spAutoFit/>
+          </a:bodyPr>
+          <a:lstStyle/>
+          <a:p>
+            <a:pPr algn="l"/>
+            <a:r>
+              <a:rPr sz="950" b="0" i="0">
                 <a:solidFill>
                   <a:srgbClr val="8A857E"/>
                 </a:solidFill>
@@ -12095,29 +12263,29 @@
       </p:sp>
       <p:sp>
         <p:nvSpPr>
-          <p:cNvPr id="30" name="TextBox 29"/>
-          <p:cNvSpPr txBox="1"/>
-          <p:nvPr/>
-        </p:nvSpPr>
-        <p:spPr>
-          <a:xfrm>
-            <a:off x="8284464" y="2926080"/>
-            <a:ext cx="3566160" cy="301752"/>
-          </a:xfrm>
-          <a:prstGeom prst="rect">
-            <a:avLst/>
-          </a:prstGeom>
-          <a:noFill/>
-        </p:spPr>
-        <p:txBody>
-          <a:bodyPr wrap="square">
-            <a:spAutoFit/>
-          </a:bodyPr>
-          <a:lstStyle/>
-          <a:p>
-            <a:pPr algn="l"/>
-            <a:r>
-              <a:rPr sz="1000" b="0" i="0">
+          <p:cNvPr id="33" name="TextBox 32"/>
+          <p:cNvSpPr txBox="1"/>
+          <p:nvPr/>
+        </p:nvSpPr>
+        <p:spPr>
+          <a:xfrm>
+            <a:off x="8266176" y="3200400"/>
+            <a:ext cx="3602736" cy="274320"/>
+          </a:xfrm>
+          <a:prstGeom prst="rect">
+            <a:avLst/>
+          </a:prstGeom>
+          <a:noFill/>
+        </p:spPr>
+        <p:txBody>
+          <a:bodyPr wrap="square">
+            <a:spAutoFit/>
+          </a:bodyPr>
+          <a:lstStyle/>
+          <a:p>
+            <a:pPr algn="l"/>
+            <a:r>
+              <a:rPr sz="950" b="0" i="0">
                 <a:solidFill>
                   <a:srgbClr val="8A857E"/>
                 </a:solidFill>
@@ -12130,29 +12298,29 @@
       </p:sp>
       <p:sp>
         <p:nvSpPr>
-          <p:cNvPr id="31" name="TextBox 30"/>
-          <p:cNvSpPr txBox="1"/>
-          <p:nvPr/>
-        </p:nvSpPr>
-        <p:spPr>
-          <a:xfrm>
-            <a:off x="8284464" y="3264408"/>
-            <a:ext cx="3566160" cy="301752"/>
-          </a:xfrm>
-          <a:prstGeom prst="rect">
-            <a:avLst/>
-          </a:prstGeom>
-          <a:noFill/>
-        </p:spPr>
-        <p:txBody>
-          <a:bodyPr wrap="square">
-            <a:spAutoFit/>
-          </a:bodyPr>
-          <a:lstStyle/>
-          <a:p>
-            <a:pPr algn="l"/>
-            <a:r>
-              <a:rPr sz="1000" b="0" i="0">
+          <p:cNvPr id="34" name="TextBox 33"/>
+          <p:cNvSpPr txBox="1"/>
+          <p:nvPr/>
+        </p:nvSpPr>
+        <p:spPr>
+          <a:xfrm>
+            <a:off x="8266176" y="3511296"/>
+            <a:ext cx="3602736" cy="274320"/>
+          </a:xfrm>
+          <a:prstGeom prst="rect">
+            <a:avLst/>
+          </a:prstGeom>
+          <a:noFill/>
+        </p:spPr>
+        <p:txBody>
+          <a:bodyPr wrap="square">
+            <a:spAutoFit/>
+          </a:bodyPr>
+          <a:lstStyle/>
+          <a:p>
+            <a:pPr algn="l"/>
+            <a:r>
+              <a:rPr sz="950" b="0" i="0">
                 <a:solidFill>
                   <a:srgbClr val="8A857E"/>
                 </a:solidFill>
@@ -12165,7 +12333,7 @@
       </p:sp>
       <p:sp>
         <p:nvSpPr>
-          <p:cNvPr id="32" name="Rectangle 31"/>
+          <p:cNvPr id="35" name="Rectangle 34"/>
           <p:cNvSpPr/>
           <p:nvPr/>
         </p:nvSpPr>
@@ -12206,33 +12374,57 @@
           </a:p>
         </p:txBody>
       </p:sp>
-      <p:sp>
-        <p:nvSpPr>
-          <p:cNvPr id="33" name="TextBox 32"/>
-          <p:cNvSpPr txBox="1"/>
-          <p:nvPr/>
-        </p:nvSpPr>
-        <p:spPr>
-          <a:xfrm>
-            <a:off x="237744" y="4123944"/>
-            <a:ext cx="548640" cy="457200"/>
-          </a:xfrm>
-          <a:prstGeom prst="rect">
-            <a:avLst/>
-          </a:prstGeom>
-          <a:noFill/>
-        </p:spPr>
-        <p:txBody>
-          <a:bodyPr wrap="square">
-            <a:spAutoFit/>
-          </a:bodyPr>
-          <a:lstStyle/>
-          <a:p>
-            <a:pPr algn="l"/>
-            <a:r>
-              <a:rPr sz="2800" b="1" i="0">
-                <a:solidFill>
-                  <a:srgbClr val="D8D3CC"/>
+      <p:pic>
+        <p:nvPicPr>
+          <p:cNvPr id="36" name="Picture 35" descr="beilin.jpg"/>
+          <p:cNvPicPr>
+            <a:picLocks noChangeAspect="1"/>
+          </p:cNvPicPr>
+          <p:nvPr/>
+        </p:nvPicPr>
+        <p:blipFill>
+          <a:blip r:embed="rId5"/>
+          <a:stretch>
+            <a:fillRect/>
+          </a:stretch>
+        </p:blipFill>
+        <p:spPr>
+          <a:xfrm>
+            <a:off x="109728" y="4041648"/>
+            <a:ext cx="3822192" cy="914400"/>
+          </a:xfrm>
+          <a:prstGeom prst="rect">
+            <a:avLst/>
+          </a:prstGeom>
+        </p:spPr>
+      </p:pic>
+      <p:sp>
+        <p:nvSpPr>
+          <p:cNvPr id="37" name="TextBox 36"/>
+          <p:cNvSpPr txBox="1"/>
+          <p:nvPr/>
+        </p:nvSpPr>
+        <p:spPr>
+          <a:xfrm>
+            <a:off x="164592" y="4059936"/>
+            <a:ext cx="502920" cy="411480"/>
+          </a:xfrm>
+          <a:prstGeom prst="rect">
+            <a:avLst/>
+          </a:prstGeom>
+          <a:noFill/>
+        </p:spPr>
+        <p:txBody>
+          <a:bodyPr wrap="square">
+            <a:spAutoFit/>
+          </a:bodyPr>
+          <a:lstStyle/>
+          <a:p>
+            <a:pPr algn="l"/>
+            <a:r>
+              <a:rPr sz="2200" b="1" i="0">
+                <a:solidFill>
+                  <a:srgbClr val="FFFFFF"/>
                 </a:solidFill>
                 <a:latin typeface="PingFang SC"/>
               </a:rPr>
@@ -12243,14 +12435,14 @@
       </p:sp>
       <p:sp>
         <p:nvSpPr>
-          <p:cNvPr id="34" name="Oval 33"/>
+          <p:cNvPr id="38" name="Oval 37"/>
           <p:cNvSpPr/>
           <p:nvPr/>
         </p:nvSpPr>
         <p:spPr>
           <a:xfrm>
-            <a:off x="3483864" y="4187952"/>
-            <a:ext cx="256032" cy="256032"/>
+            <a:off x="3529584" y="4096512"/>
+            <a:ext cx="237744" cy="237744"/>
           </a:xfrm>
           <a:prstGeom prst="ellipse">
             <a:avLst/>
@@ -12286,29 +12478,29 @@
       </p:sp>
       <p:sp>
         <p:nvSpPr>
-          <p:cNvPr id="35" name="TextBox 34"/>
-          <p:cNvSpPr txBox="1"/>
-          <p:nvPr/>
-        </p:nvSpPr>
-        <p:spPr>
-          <a:xfrm>
-            <a:off x="237744" y="4608576"/>
-            <a:ext cx="3566160" cy="411480"/>
-          </a:xfrm>
-          <a:prstGeom prst="rect">
-            <a:avLst/>
-          </a:prstGeom>
-          <a:noFill/>
-        </p:spPr>
-        <p:txBody>
-          <a:bodyPr wrap="square">
-            <a:spAutoFit/>
-          </a:bodyPr>
-          <a:lstStyle/>
-          <a:p>
-            <a:pPr algn="l"/>
-            <a:r>
-              <a:rPr sz="1700" b="1" i="0">
+          <p:cNvPr id="39" name="TextBox 38"/>
+          <p:cNvSpPr txBox="1"/>
+          <p:nvPr/>
+        </p:nvSpPr>
+        <p:spPr>
+          <a:xfrm>
+            <a:off x="219456" y="4992624"/>
+            <a:ext cx="3602736" cy="384048"/>
+          </a:xfrm>
+          <a:prstGeom prst="rect">
+            <a:avLst/>
+          </a:prstGeom>
+          <a:noFill/>
+        </p:spPr>
+        <p:txBody>
+          <a:bodyPr wrap="square">
+            <a:spAutoFit/>
+          </a:bodyPr>
+          <a:lstStyle/>
+          <a:p>
+            <a:pPr algn="l"/>
+            <a:r>
+              <a:rPr sz="1500" b="1" i="0">
                 <a:solidFill>
                   <a:srgbClr val="1E1A17"/>
                 </a:solidFill>
@@ -12321,29 +12513,29 @@
       </p:sp>
       <p:sp>
         <p:nvSpPr>
-          <p:cNvPr id="36" name="TextBox 35"/>
-          <p:cNvSpPr txBox="1"/>
-          <p:nvPr/>
-        </p:nvSpPr>
-        <p:spPr>
-          <a:xfrm>
-            <a:off x="237744" y="4992624"/>
-            <a:ext cx="3566160" cy="274320"/>
-          </a:xfrm>
-          <a:prstGeom prst="rect">
-            <a:avLst/>
-          </a:prstGeom>
-          <a:noFill/>
-        </p:spPr>
-        <p:txBody>
-          <a:bodyPr wrap="square">
-            <a:spAutoFit/>
-          </a:bodyPr>
-          <a:lstStyle/>
-          <a:p>
-            <a:pPr algn="l"/>
-            <a:r>
-              <a:rPr sz="900" b="0" i="0">
+          <p:cNvPr id="40" name="TextBox 39"/>
+          <p:cNvSpPr txBox="1"/>
+          <p:nvPr/>
+        </p:nvSpPr>
+        <p:spPr>
+          <a:xfrm>
+            <a:off x="219456" y="5358384"/>
+            <a:ext cx="3602736" cy="228600"/>
+          </a:xfrm>
+          <a:prstGeom prst="rect">
+            <a:avLst/>
+          </a:prstGeom>
+          <a:noFill/>
+        </p:spPr>
+        <p:txBody>
+          <a:bodyPr wrap="square">
+            <a:spAutoFit/>
+          </a:bodyPr>
+          <a:lstStyle/>
+          <a:p>
+            <a:pPr algn="l"/>
+            <a:r>
+              <a:rPr sz="800" b="0" i="0">
                 <a:solidFill>
                   <a:srgbClr val="8A857E"/>
                 </a:solidFill>
@@ -12356,29 +12548,29 @@
       </p:sp>
       <p:sp>
         <p:nvSpPr>
-          <p:cNvPr id="37" name="TextBox 36"/>
-          <p:cNvSpPr txBox="1"/>
-          <p:nvPr/>
-        </p:nvSpPr>
-        <p:spPr>
-          <a:xfrm>
-            <a:off x="237744" y="5312664"/>
-            <a:ext cx="3566160" cy="301752"/>
-          </a:xfrm>
-          <a:prstGeom prst="rect">
-            <a:avLst/>
-          </a:prstGeom>
-          <a:noFill/>
-        </p:spPr>
-        <p:txBody>
-          <a:bodyPr wrap="square">
-            <a:spAutoFit/>
-          </a:bodyPr>
-          <a:lstStyle/>
-          <a:p>
-            <a:pPr algn="l"/>
-            <a:r>
-              <a:rPr sz="1000" b="0" i="0">
+          <p:cNvPr id="41" name="TextBox 40"/>
+          <p:cNvSpPr txBox="1"/>
+          <p:nvPr/>
+        </p:nvSpPr>
+        <p:spPr>
+          <a:xfrm>
+            <a:off x="219456" y="5614416"/>
+            <a:ext cx="3602736" cy="274320"/>
+          </a:xfrm>
+          <a:prstGeom prst="rect">
+            <a:avLst/>
+          </a:prstGeom>
+          <a:noFill/>
+        </p:spPr>
+        <p:txBody>
+          <a:bodyPr wrap="square">
+            <a:spAutoFit/>
+          </a:bodyPr>
+          <a:lstStyle/>
+          <a:p>
+            <a:pPr algn="l"/>
+            <a:r>
+              <a:rPr sz="950" b="0" i="0">
                 <a:solidFill>
                   <a:srgbClr val="8A857E"/>
                 </a:solidFill>
@@ -12391,29 +12583,29 @@
       </p:sp>
       <p:sp>
         <p:nvSpPr>
-          <p:cNvPr id="38" name="TextBox 37"/>
-          <p:cNvSpPr txBox="1"/>
-          <p:nvPr/>
-        </p:nvSpPr>
-        <p:spPr>
-          <a:xfrm>
-            <a:off x="237744" y="5650992"/>
-            <a:ext cx="3566160" cy="301752"/>
-          </a:xfrm>
-          <a:prstGeom prst="rect">
-            <a:avLst/>
-          </a:prstGeom>
-          <a:noFill/>
-        </p:spPr>
-        <p:txBody>
-          <a:bodyPr wrap="square">
-            <a:spAutoFit/>
-          </a:bodyPr>
-          <a:lstStyle/>
-          <a:p>
-            <a:pPr algn="l"/>
-            <a:r>
-              <a:rPr sz="1000" b="0" i="0">
+          <p:cNvPr id="42" name="TextBox 41"/>
+          <p:cNvSpPr txBox="1"/>
+          <p:nvPr/>
+        </p:nvSpPr>
+        <p:spPr>
+          <a:xfrm>
+            <a:off x="219456" y="5925312"/>
+            <a:ext cx="3602736" cy="274320"/>
+          </a:xfrm>
+          <a:prstGeom prst="rect">
+            <a:avLst/>
+          </a:prstGeom>
+          <a:noFill/>
+        </p:spPr>
+        <p:txBody>
+          <a:bodyPr wrap="square">
+            <a:spAutoFit/>
+          </a:bodyPr>
+          <a:lstStyle/>
+          <a:p>
+            <a:pPr algn="l"/>
+            <a:r>
+              <a:rPr sz="950" b="0" i="0">
                 <a:solidFill>
                   <a:srgbClr val="8A857E"/>
                 </a:solidFill>
@@ -12426,29 +12618,29 @@
       </p:sp>
       <p:sp>
         <p:nvSpPr>
-          <p:cNvPr id="39" name="TextBox 38"/>
-          <p:cNvSpPr txBox="1"/>
-          <p:nvPr/>
-        </p:nvSpPr>
-        <p:spPr>
-          <a:xfrm>
-            <a:off x="237744" y="5989320"/>
-            <a:ext cx="3566160" cy="301752"/>
-          </a:xfrm>
-          <a:prstGeom prst="rect">
-            <a:avLst/>
-          </a:prstGeom>
-          <a:noFill/>
-        </p:spPr>
-        <p:txBody>
-          <a:bodyPr wrap="square">
-            <a:spAutoFit/>
-          </a:bodyPr>
-          <a:lstStyle/>
-          <a:p>
-            <a:pPr algn="l"/>
-            <a:r>
-              <a:rPr sz="1000" b="0" i="0">
+          <p:cNvPr id="43" name="TextBox 42"/>
+          <p:cNvSpPr txBox="1"/>
+          <p:nvPr/>
+        </p:nvSpPr>
+        <p:spPr>
+          <a:xfrm>
+            <a:off x="219456" y="6236208"/>
+            <a:ext cx="3602736" cy="274320"/>
+          </a:xfrm>
+          <a:prstGeom prst="rect">
+            <a:avLst/>
+          </a:prstGeom>
+          <a:noFill/>
+        </p:spPr>
+        <p:txBody>
+          <a:bodyPr wrap="square">
+            <a:spAutoFit/>
+          </a:bodyPr>
+          <a:lstStyle/>
+          <a:p>
+            <a:pPr algn="l"/>
+            <a:r>
+              <a:rPr sz="950" b="0" i="0">
                 <a:solidFill>
                   <a:srgbClr val="8A857E"/>
                 </a:solidFill>
@@ -12461,7 +12653,7 @@
       </p:sp>
       <p:sp>
         <p:nvSpPr>
-          <p:cNvPr id="40" name="Rectangle 39"/>
+          <p:cNvPr id="44" name="Rectangle 43"/>
           <p:cNvSpPr/>
           <p:nvPr/>
         </p:nvSpPr>
@@ -12502,33 +12694,57 @@
           </a:p>
         </p:txBody>
       </p:sp>
-      <p:sp>
-        <p:nvSpPr>
-          <p:cNvPr id="41" name="TextBox 40"/>
-          <p:cNvSpPr txBox="1"/>
-          <p:nvPr/>
-        </p:nvSpPr>
-        <p:spPr>
-          <a:xfrm>
-            <a:off x="4261104" y="4123944"/>
-            <a:ext cx="548640" cy="457200"/>
-          </a:xfrm>
-          <a:prstGeom prst="rect">
-            <a:avLst/>
-          </a:prstGeom>
-          <a:noFill/>
-        </p:spPr>
-        <p:txBody>
-          <a:bodyPr wrap="square">
-            <a:spAutoFit/>
-          </a:bodyPr>
-          <a:lstStyle/>
-          <a:p>
-            <a:pPr algn="l"/>
-            <a:r>
-              <a:rPr sz="2800" b="1" i="0">
-                <a:solidFill>
-                  <a:srgbClr val="D8D3CC"/>
+      <p:pic>
+        <p:nvPicPr>
+          <p:cNvPr id="45" name="Picture 44" descr="library.jpg"/>
+          <p:cNvPicPr>
+            <a:picLocks noChangeAspect="1"/>
+          </p:cNvPicPr>
+          <p:nvPr/>
+        </p:nvPicPr>
+        <p:blipFill>
+          <a:blip r:embed="rId6"/>
+          <a:stretch>
+            <a:fillRect/>
+          </a:stretch>
+        </p:blipFill>
+        <p:spPr>
+          <a:xfrm>
+            <a:off x="4133088" y="4041648"/>
+            <a:ext cx="3822192" cy="914400"/>
+          </a:xfrm>
+          <a:prstGeom prst="rect">
+            <a:avLst/>
+          </a:prstGeom>
+        </p:spPr>
+      </p:pic>
+      <p:sp>
+        <p:nvSpPr>
+          <p:cNvPr id="46" name="TextBox 45"/>
+          <p:cNvSpPr txBox="1"/>
+          <p:nvPr/>
+        </p:nvSpPr>
+        <p:spPr>
+          <a:xfrm>
+            <a:off x="4187952" y="4059936"/>
+            <a:ext cx="502920" cy="411480"/>
+          </a:xfrm>
+          <a:prstGeom prst="rect">
+            <a:avLst/>
+          </a:prstGeom>
+          <a:noFill/>
+        </p:spPr>
+        <p:txBody>
+          <a:bodyPr wrap="square">
+            <a:spAutoFit/>
+          </a:bodyPr>
+          <a:lstStyle/>
+          <a:p>
+            <a:pPr algn="l"/>
+            <a:r>
+              <a:rPr sz="2200" b="1" i="0">
+                <a:solidFill>
+                  <a:srgbClr val="FFFFFF"/>
                 </a:solidFill>
                 <a:latin typeface="PingFang SC"/>
               </a:rPr>
@@ -12539,14 +12755,14 @@
       </p:sp>
       <p:sp>
         <p:nvSpPr>
-          <p:cNvPr id="42" name="Oval 41"/>
+          <p:cNvPr id="47" name="Oval 46"/>
           <p:cNvSpPr/>
           <p:nvPr/>
         </p:nvSpPr>
         <p:spPr>
           <a:xfrm>
-            <a:off x="7507224" y="4187952"/>
-            <a:ext cx="256032" cy="256032"/>
+            <a:off x="7552944" y="4096512"/>
+            <a:ext cx="237744" cy="237744"/>
           </a:xfrm>
           <a:prstGeom prst="ellipse">
             <a:avLst/>
@@ -12582,29 +12798,29 @@
       </p:sp>
       <p:sp>
         <p:nvSpPr>
-          <p:cNvPr id="43" name="TextBox 42"/>
-          <p:cNvSpPr txBox="1"/>
-          <p:nvPr/>
-        </p:nvSpPr>
-        <p:spPr>
-          <a:xfrm>
-            <a:off x="4261104" y="4608576"/>
-            <a:ext cx="3566160" cy="411480"/>
-          </a:xfrm>
-          <a:prstGeom prst="rect">
-            <a:avLst/>
-          </a:prstGeom>
-          <a:noFill/>
-        </p:spPr>
-        <p:txBody>
-          <a:bodyPr wrap="square">
-            <a:spAutoFit/>
-          </a:bodyPr>
-          <a:lstStyle/>
-          <a:p>
-            <a:pPr algn="l"/>
-            <a:r>
-              <a:rPr sz="1700" b="1" i="0">
+          <p:cNvPr id="48" name="TextBox 47"/>
+          <p:cNvSpPr txBox="1"/>
+          <p:nvPr/>
+        </p:nvSpPr>
+        <p:spPr>
+          <a:xfrm>
+            <a:off x="4242816" y="4992624"/>
+            <a:ext cx="3602736" cy="384048"/>
+          </a:xfrm>
+          <a:prstGeom prst="rect">
+            <a:avLst/>
+          </a:prstGeom>
+          <a:noFill/>
+        </p:spPr>
+        <p:txBody>
+          <a:bodyPr wrap="square">
+            <a:spAutoFit/>
+          </a:bodyPr>
+          <a:lstStyle/>
+          <a:p>
+            <a:pPr algn="l"/>
+            <a:r>
+              <a:rPr sz="1500" b="1" i="0">
                 <a:solidFill>
                   <a:srgbClr val="1E1A17"/>
                 </a:solidFill>
@@ -12617,29 +12833,29 @@
       </p:sp>
       <p:sp>
         <p:nvSpPr>
-          <p:cNvPr id="44" name="TextBox 43"/>
-          <p:cNvSpPr txBox="1"/>
-          <p:nvPr/>
-        </p:nvSpPr>
-        <p:spPr>
-          <a:xfrm>
-            <a:off x="4261104" y="4992624"/>
-            <a:ext cx="3566160" cy="274320"/>
-          </a:xfrm>
-          <a:prstGeom prst="rect">
-            <a:avLst/>
-          </a:prstGeom>
-          <a:noFill/>
-        </p:spPr>
-        <p:txBody>
-          <a:bodyPr wrap="square">
-            <a:spAutoFit/>
-          </a:bodyPr>
-          <a:lstStyle/>
-          <a:p>
-            <a:pPr algn="l"/>
-            <a:r>
-              <a:rPr sz="900" b="0" i="0">
+          <p:cNvPr id="49" name="TextBox 48"/>
+          <p:cNvSpPr txBox="1"/>
+          <p:nvPr/>
+        </p:nvSpPr>
+        <p:spPr>
+          <a:xfrm>
+            <a:off x="4242816" y="5358384"/>
+            <a:ext cx="3602736" cy="228600"/>
+          </a:xfrm>
+          <a:prstGeom prst="rect">
+            <a:avLst/>
+          </a:prstGeom>
+          <a:noFill/>
+        </p:spPr>
+        <p:txBody>
+          <a:bodyPr wrap="square">
+            <a:spAutoFit/>
+          </a:bodyPr>
+          <a:lstStyle/>
+          <a:p>
+            <a:pPr algn="l"/>
+            <a:r>
+              <a:rPr sz="800" b="0" i="0">
                 <a:solidFill>
                   <a:srgbClr val="8A857E"/>
                 </a:solidFill>
@@ -12652,29 +12868,29 @@
       </p:sp>
       <p:sp>
         <p:nvSpPr>
-          <p:cNvPr id="45" name="TextBox 44"/>
-          <p:cNvSpPr txBox="1"/>
-          <p:nvPr/>
-        </p:nvSpPr>
-        <p:spPr>
-          <a:xfrm>
-            <a:off x="4261104" y="5312664"/>
-            <a:ext cx="3566160" cy="301752"/>
-          </a:xfrm>
-          <a:prstGeom prst="rect">
-            <a:avLst/>
-          </a:prstGeom>
-          <a:noFill/>
-        </p:spPr>
-        <p:txBody>
-          <a:bodyPr wrap="square">
-            <a:spAutoFit/>
-          </a:bodyPr>
-          <a:lstStyle/>
-          <a:p>
-            <a:pPr algn="l"/>
-            <a:r>
-              <a:rPr sz="1000" b="0" i="0">
+          <p:cNvPr id="50" name="TextBox 49"/>
+          <p:cNvSpPr txBox="1"/>
+          <p:nvPr/>
+        </p:nvSpPr>
+        <p:spPr>
+          <a:xfrm>
+            <a:off x="4242816" y="5614416"/>
+            <a:ext cx="3602736" cy="274320"/>
+          </a:xfrm>
+          <a:prstGeom prst="rect">
+            <a:avLst/>
+          </a:prstGeom>
+          <a:noFill/>
+        </p:spPr>
+        <p:txBody>
+          <a:bodyPr wrap="square">
+            <a:spAutoFit/>
+          </a:bodyPr>
+          <a:lstStyle/>
+          <a:p>
+            <a:pPr algn="l"/>
+            <a:r>
+              <a:rPr sz="950" b="0" i="0">
                 <a:solidFill>
                   <a:srgbClr val="8A857E"/>
                 </a:solidFill>
@@ -12687,29 +12903,29 @@
       </p:sp>
       <p:sp>
         <p:nvSpPr>
-          <p:cNvPr id="46" name="TextBox 45"/>
-          <p:cNvSpPr txBox="1"/>
-          <p:nvPr/>
-        </p:nvSpPr>
-        <p:spPr>
-          <a:xfrm>
-            <a:off x="4261104" y="5650992"/>
-            <a:ext cx="3566160" cy="301752"/>
-          </a:xfrm>
-          <a:prstGeom prst="rect">
-            <a:avLst/>
-          </a:prstGeom>
-          <a:noFill/>
-        </p:spPr>
-        <p:txBody>
-          <a:bodyPr wrap="square">
-            <a:spAutoFit/>
-          </a:bodyPr>
-          <a:lstStyle/>
-          <a:p>
-            <a:pPr algn="l"/>
-            <a:r>
-              <a:rPr sz="1000" b="0" i="0">
+          <p:cNvPr id="51" name="TextBox 50"/>
+          <p:cNvSpPr txBox="1"/>
+          <p:nvPr/>
+        </p:nvSpPr>
+        <p:spPr>
+          <a:xfrm>
+            <a:off x="4242816" y="5925312"/>
+            <a:ext cx="3602736" cy="274320"/>
+          </a:xfrm>
+          <a:prstGeom prst="rect">
+            <a:avLst/>
+          </a:prstGeom>
+          <a:noFill/>
+        </p:spPr>
+        <p:txBody>
+          <a:bodyPr wrap="square">
+            <a:spAutoFit/>
+          </a:bodyPr>
+          <a:lstStyle/>
+          <a:p>
+            <a:pPr algn="l"/>
+            <a:r>
+              <a:rPr sz="950" b="0" i="0">
                 <a:solidFill>
                   <a:srgbClr val="8A857E"/>
                 </a:solidFill>
@@ -12722,29 +12938,29 @@
       </p:sp>
       <p:sp>
         <p:nvSpPr>
-          <p:cNvPr id="47" name="TextBox 46"/>
-          <p:cNvSpPr txBox="1"/>
-          <p:nvPr/>
-        </p:nvSpPr>
-        <p:spPr>
-          <a:xfrm>
-            <a:off x="4261104" y="5989320"/>
-            <a:ext cx="3566160" cy="301752"/>
-          </a:xfrm>
-          <a:prstGeom prst="rect">
-            <a:avLst/>
-          </a:prstGeom>
-          <a:noFill/>
-        </p:spPr>
-        <p:txBody>
-          <a:bodyPr wrap="square">
-            <a:spAutoFit/>
-          </a:bodyPr>
-          <a:lstStyle/>
-          <a:p>
-            <a:pPr algn="l"/>
-            <a:r>
-              <a:rPr sz="1000" b="0" i="0">
+          <p:cNvPr id="52" name="TextBox 51"/>
+          <p:cNvSpPr txBox="1"/>
+          <p:nvPr/>
+        </p:nvSpPr>
+        <p:spPr>
+          <a:xfrm>
+            <a:off x="4242816" y="6236208"/>
+            <a:ext cx="3602736" cy="274320"/>
+          </a:xfrm>
+          <a:prstGeom prst="rect">
+            <a:avLst/>
+          </a:prstGeom>
+          <a:noFill/>
+        </p:spPr>
+        <p:txBody>
+          <a:bodyPr wrap="square">
+            <a:spAutoFit/>
+          </a:bodyPr>
+          <a:lstStyle/>
+          <a:p>
+            <a:pPr algn="l"/>
+            <a:r>
+              <a:rPr sz="950" b="0" i="0">
                 <a:solidFill>
                   <a:srgbClr val="8A857E"/>
                 </a:solidFill>
@@ -12757,7 +12973,7 @@
       </p:sp>
       <p:sp>
         <p:nvSpPr>
-          <p:cNvPr id="48" name="Rectangle 47"/>
+          <p:cNvPr id="53" name="Rectangle 52"/>
           <p:cNvSpPr/>
           <p:nvPr/>
         </p:nvSpPr>
@@ -12798,33 +13014,57 @@
           </a:p>
         </p:txBody>
       </p:sp>
-      <p:sp>
-        <p:nvSpPr>
-          <p:cNvPr id="49" name="TextBox 48"/>
-          <p:cNvSpPr txBox="1"/>
-          <p:nvPr/>
-        </p:nvSpPr>
-        <p:spPr>
-          <a:xfrm>
-            <a:off x="8284464" y="4123944"/>
-            <a:ext cx="548640" cy="457200"/>
-          </a:xfrm>
-          <a:prstGeom prst="rect">
-            <a:avLst/>
-          </a:prstGeom>
-          <a:noFill/>
-        </p:spPr>
-        <p:txBody>
-          <a:bodyPr wrap="square">
-            <a:spAutoFit/>
-          </a:bodyPr>
-          <a:lstStyle/>
-          <a:p>
-            <a:pPr algn="l"/>
-            <a:r>
-              <a:rPr sz="2800" b="1" i="0">
-                <a:solidFill>
-                  <a:srgbClr val="D8D3CC"/>
+      <p:pic>
+        <p:nvPicPr>
+          <p:cNvPr id="54" name="Picture 53" descr="noncultural.jpg"/>
+          <p:cNvPicPr>
+            <a:picLocks noChangeAspect="1"/>
+          </p:cNvPicPr>
+          <p:nvPr/>
+        </p:nvPicPr>
+        <p:blipFill>
+          <a:blip r:embed="rId7"/>
+          <a:stretch>
+            <a:fillRect/>
+          </a:stretch>
+        </p:blipFill>
+        <p:spPr>
+          <a:xfrm>
+            <a:off x="8156448" y="4041648"/>
+            <a:ext cx="3822192" cy="914400"/>
+          </a:xfrm>
+          <a:prstGeom prst="rect">
+            <a:avLst/>
+          </a:prstGeom>
+        </p:spPr>
+      </p:pic>
+      <p:sp>
+        <p:nvSpPr>
+          <p:cNvPr id="55" name="TextBox 54"/>
+          <p:cNvSpPr txBox="1"/>
+          <p:nvPr/>
+        </p:nvSpPr>
+        <p:spPr>
+          <a:xfrm>
+            <a:off x="8211312" y="4059936"/>
+            <a:ext cx="502920" cy="411480"/>
+          </a:xfrm>
+          <a:prstGeom prst="rect">
+            <a:avLst/>
+          </a:prstGeom>
+          <a:noFill/>
+        </p:spPr>
+        <p:txBody>
+          <a:bodyPr wrap="square">
+            <a:spAutoFit/>
+          </a:bodyPr>
+          <a:lstStyle/>
+          <a:p>
+            <a:pPr algn="l"/>
+            <a:r>
+              <a:rPr sz="2200" b="1" i="0">
+                <a:solidFill>
+                  <a:srgbClr val="FFFFFF"/>
                 </a:solidFill>
                 <a:latin typeface="PingFang SC"/>
               </a:rPr>
@@ -12835,14 +13075,14 @@
       </p:sp>
       <p:sp>
         <p:nvSpPr>
-          <p:cNvPr id="50" name="Oval 49"/>
+          <p:cNvPr id="56" name="Oval 55"/>
           <p:cNvSpPr/>
           <p:nvPr/>
         </p:nvSpPr>
         <p:spPr>
           <a:xfrm>
-            <a:off x="11530584" y="4187952"/>
-            <a:ext cx="256032" cy="256032"/>
+            <a:off x="11576304" y="4096512"/>
+            <a:ext cx="237744" cy="237744"/>
           </a:xfrm>
           <a:prstGeom prst="ellipse">
             <a:avLst/>
@@ -12878,29 +13118,29 @@
       </p:sp>
       <p:sp>
         <p:nvSpPr>
-          <p:cNvPr id="51" name="TextBox 50"/>
-          <p:cNvSpPr txBox="1"/>
-          <p:nvPr/>
-        </p:nvSpPr>
-        <p:spPr>
-          <a:xfrm>
-            <a:off x="8284464" y="4608576"/>
-            <a:ext cx="3566160" cy="411480"/>
-          </a:xfrm>
-          <a:prstGeom prst="rect">
-            <a:avLst/>
-          </a:prstGeom>
-          <a:noFill/>
-        </p:spPr>
-        <p:txBody>
-          <a:bodyPr wrap="square">
-            <a:spAutoFit/>
-          </a:bodyPr>
-          <a:lstStyle/>
-          <a:p>
-            <a:pPr algn="l"/>
-            <a:r>
-              <a:rPr sz="1700" b="1" i="0">
+          <p:cNvPr id="57" name="TextBox 56"/>
+          <p:cNvSpPr txBox="1"/>
+          <p:nvPr/>
+        </p:nvSpPr>
+        <p:spPr>
+          <a:xfrm>
+            <a:off x="8266176" y="4992624"/>
+            <a:ext cx="3602736" cy="384048"/>
+          </a:xfrm>
+          <a:prstGeom prst="rect">
+            <a:avLst/>
+          </a:prstGeom>
+          <a:noFill/>
+        </p:spPr>
+        <p:txBody>
+          <a:bodyPr wrap="square">
+            <a:spAutoFit/>
+          </a:bodyPr>
+          <a:lstStyle/>
+          <a:p>
+            <a:pPr algn="l"/>
+            <a:r>
+              <a:rPr sz="1500" b="1" i="0">
                 <a:solidFill>
                   <a:srgbClr val="1E1A17"/>
                 </a:solidFill>
@@ -12913,29 +13153,29 @@
       </p:sp>
       <p:sp>
         <p:nvSpPr>
-          <p:cNvPr id="52" name="TextBox 51"/>
-          <p:cNvSpPr txBox="1"/>
-          <p:nvPr/>
-        </p:nvSpPr>
-        <p:spPr>
-          <a:xfrm>
-            <a:off x="8284464" y="4992624"/>
-            <a:ext cx="3566160" cy="274320"/>
-          </a:xfrm>
-          <a:prstGeom prst="rect">
-            <a:avLst/>
-          </a:prstGeom>
-          <a:noFill/>
-        </p:spPr>
-        <p:txBody>
-          <a:bodyPr wrap="square">
-            <a:spAutoFit/>
-          </a:bodyPr>
-          <a:lstStyle/>
-          <a:p>
-            <a:pPr algn="l"/>
-            <a:r>
-              <a:rPr sz="900" b="0" i="0">
+          <p:cNvPr id="58" name="TextBox 57"/>
+          <p:cNvSpPr txBox="1"/>
+          <p:nvPr/>
+        </p:nvSpPr>
+        <p:spPr>
+          <a:xfrm>
+            <a:off x="8266176" y="5358384"/>
+            <a:ext cx="3602736" cy="228600"/>
+          </a:xfrm>
+          <a:prstGeom prst="rect">
+            <a:avLst/>
+          </a:prstGeom>
+          <a:noFill/>
+        </p:spPr>
+        <p:txBody>
+          <a:bodyPr wrap="square">
+            <a:spAutoFit/>
+          </a:bodyPr>
+          <a:lstStyle/>
+          <a:p>
+            <a:pPr algn="l"/>
+            <a:r>
+              <a:rPr sz="800" b="0" i="0">
                 <a:solidFill>
                   <a:srgbClr val="8A857E"/>
                 </a:solidFill>
@@ -12948,29 +13188,29 @@
       </p:sp>
       <p:sp>
         <p:nvSpPr>
-          <p:cNvPr id="53" name="TextBox 52"/>
-          <p:cNvSpPr txBox="1"/>
-          <p:nvPr/>
-        </p:nvSpPr>
-        <p:spPr>
-          <a:xfrm>
-            <a:off x="8284464" y="5312664"/>
-            <a:ext cx="3566160" cy="301752"/>
-          </a:xfrm>
-          <a:prstGeom prst="rect">
-            <a:avLst/>
-          </a:prstGeom>
-          <a:noFill/>
-        </p:spPr>
-        <p:txBody>
-          <a:bodyPr wrap="square">
-            <a:spAutoFit/>
-          </a:bodyPr>
-          <a:lstStyle/>
-          <a:p>
-            <a:pPr algn="l"/>
-            <a:r>
-              <a:rPr sz="1000" b="0" i="0">
+          <p:cNvPr id="59" name="TextBox 58"/>
+          <p:cNvSpPr txBox="1"/>
+          <p:nvPr/>
+        </p:nvSpPr>
+        <p:spPr>
+          <a:xfrm>
+            <a:off x="8266176" y="5614416"/>
+            <a:ext cx="3602736" cy="274320"/>
+          </a:xfrm>
+          <a:prstGeom prst="rect">
+            <a:avLst/>
+          </a:prstGeom>
+          <a:noFill/>
+        </p:spPr>
+        <p:txBody>
+          <a:bodyPr wrap="square">
+            <a:spAutoFit/>
+          </a:bodyPr>
+          <a:lstStyle/>
+          <a:p>
+            <a:pPr algn="l"/>
+            <a:r>
+              <a:rPr sz="950" b="0" i="0">
                 <a:solidFill>
                   <a:srgbClr val="8A857E"/>
                 </a:solidFill>
@@ -12983,29 +13223,29 @@
       </p:sp>
       <p:sp>
         <p:nvSpPr>
-          <p:cNvPr id="54" name="TextBox 53"/>
-          <p:cNvSpPr txBox="1"/>
-          <p:nvPr/>
-        </p:nvSpPr>
-        <p:spPr>
-          <a:xfrm>
-            <a:off x="8284464" y="5650992"/>
-            <a:ext cx="3566160" cy="301752"/>
-          </a:xfrm>
-          <a:prstGeom prst="rect">
-            <a:avLst/>
-          </a:prstGeom>
-          <a:noFill/>
-        </p:spPr>
-        <p:txBody>
-          <a:bodyPr wrap="square">
-            <a:spAutoFit/>
-          </a:bodyPr>
-          <a:lstStyle/>
-          <a:p>
-            <a:pPr algn="l"/>
-            <a:r>
-              <a:rPr sz="1000" b="0" i="0">
+          <p:cNvPr id="60" name="TextBox 59"/>
+          <p:cNvSpPr txBox="1"/>
+          <p:nvPr/>
+        </p:nvSpPr>
+        <p:spPr>
+          <a:xfrm>
+            <a:off x="8266176" y="5925312"/>
+            <a:ext cx="3602736" cy="274320"/>
+          </a:xfrm>
+          <a:prstGeom prst="rect">
+            <a:avLst/>
+          </a:prstGeom>
+          <a:noFill/>
+        </p:spPr>
+        <p:txBody>
+          <a:bodyPr wrap="square">
+            <a:spAutoFit/>
+          </a:bodyPr>
+          <a:lstStyle/>
+          <a:p>
+            <a:pPr algn="l"/>
+            <a:r>
+              <a:rPr sz="950" b="0" i="0">
                 <a:solidFill>
                   <a:srgbClr val="8A857E"/>
                 </a:solidFill>
@@ -13018,29 +13258,29 @@
       </p:sp>
       <p:sp>
         <p:nvSpPr>
-          <p:cNvPr id="55" name="TextBox 54"/>
-          <p:cNvSpPr txBox="1"/>
-          <p:nvPr/>
-        </p:nvSpPr>
-        <p:spPr>
-          <a:xfrm>
-            <a:off x="8284464" y="5989320"/>
-            <a:ext cx="3566160" cy="301752"/>
-          </a:xfrm>
-          <a:prstGeom prst="rect">
-            <a:avLst/>
-          </a:prstGeom>
-          <a:noFill/>
-        </p:spPr>
-        <p:txBody>
-          <a:bodyPr wrap="square">
-            <a:spAutoFit/>
-          </a:bodyPr>
-          <a:lstStyle/>
-          <a:p>
-            <a:pPr algn="l"/>
-            <a:r>
-              <a:rPr sz="1000" b="0" i="0">
+          <p:cNvPr id="61" name="TextBox 60"/>
+          <p:cNvSpPr txBox="1"/>
+          <p:nvPr/>
+        </p:nvSpPr>
+        <p:spPr>
+          <a:xfrm>
+            <a:off x="8266176" y="6236208"/>
+            <a:ext cx="3602736" cy="274320"/>
+          </a:xfrm>
+          <a:prstGeom prst="rect">
+            <a:avLst/>
+          </a:prstGeom>
+          <a:noFill/>
+        </p:spPr>
+        <p:txBody>
+          <a:bodyPr wrap="square">
+            <a:spAutoFit/>
+          </a:bodyPr>
+          <a:lstStyle/>
+          <a:p>
+            <a:pPr algn="l"/>
+            <a:r>
+              <a:rPr sz="950" b="0" i="0">
                 <a:solidFill>
                   <a:srgbClr val="8A857E"/>
                 </a:solidFill>

</xml_diff>